<commit_message>
Minor changes y analisis correctos en la presentacion creada
</commit_message>
<xml_diff>
--- a/OUTPUTS/presentacion_final.pptx
+++ b/OUTPUTS/presentacion_final.pptx
@@ -3278,7 +3278,7 @@
                 </a:solidFill>
                 <a:latin typeface="Aptos"/>
               </a:rPr>
-              <a:t>Analisis 05: Que distingue a los jovenes con alto potencial?</a:t>
+              <a:t>Analisis 05: ¿Qué distingue a los jovenes con alto potencial?</a:t>
             </a:r>
           </a:p>
         </p:txBody>
@@ -3363,7 +3363,7 @@
                 </a:solidFill>
                 <a:latin typeface="Aptos"/>
               </a:rPr>
-              <a:t>Lectura del analisis 05: Que distingue a los jovenes con alto potencial?</a:t>
+              <a:t>Lectura del análisis 05: ¿Qué distingue a los jovenes con alto potencial?</a:t>
             </a:r>
           </a:p>
         </p:txBody>
@@ -3402,7 +3402,7 @@
                 </a:solidFill>
                 <a:latin typeface="Aptos"/>
               </a:rPr>
-              <a:t>En este gráfico se observa que los jugadores jóvenes de alto potencial no se diferencian tanto por atributos defensivos o físicos puros, sino sobre todo por rasgos técnicos y ofensivos. Los atributos que más sobresalen son DRIBBLING, CURVE, BALL_CONTROL, LONG_SHOTS, POSITIONING y VISION, lo que sugiere que el techo de desarrollo suele estar más asociado con calidad técnica y capacidad ofensiva que con fuerza o juego defensivo.</a:t>
+              <a:t>Los jugadores jóvenes con mayor potencial destacan principalmente por atributos técnicos y ofensivos, más que por capacidades físicas o defensivas. DRIBBLING, CURVE, BALL_CONTROL y LONG_SHOTS son las variables con mayor diferencia respecto al grupo de referencia, lo que sugiere que el principal desarrollo está más asociado con calidad técnica, creatividad y capacidad para generar jugadas ofensivas que con atributos defensivos tradicionales. También sobresalen POSITIONING y VISION, indicando que la lectura de juego y la toma de decisiones son factores importantes en perfiles con alto potencial.</a:t>
             </a:r>
           </a:p>
           <a:p>
@@ -3418,23 +3418,7 @@
                 </a:solidFill>
                 <a:latin typeface="Aptos"/>
               </a:rPr>
-              <a:t>También destaca que SHORT_PASSING, CROSSING, SHOT_POWER y REACTIONS aparecen entre las diferencias más altas. Esto sugiere que los jugadores más prometedores no solo tienen habilidad individual, sino también mejores recursos para participar en la circulación del balón y resolver jugadas con más calidad.</a:t>
-            </a:r>
-          </a:p>
-          <a:p>
-            <a:pPr>
-              <a:spcAft>
-                <a:spcPts val="1000"/>
-              </a:spcAft>
-            </a:pPr>
-            <a:r>
-              <a:rPr sz="1800">
-                <a:solidFill>
-                  <a:srgbClr val="1F2937"/>
-                </a:solidFill>
-                <a:latin typeface="Aptos"/>
-              </a:rPr>
-              <a:t>En conjunto, el gráfico sugiere que, al buscar talento joven con margen de crecimiento, conviene priorizar perfiles con buena técnica ofensiva, control de balón y lectura de juego. De todos modos, este resultado debe interpretarse como una asociación y no como causalidad, ya que tener estos atributos no garantiza por sí solo que un jugador alcance su potencial.</a:t>
+              <a:t>Desde la perspectiva de scouting, el gráfico sugiere que varios atributos pueden agruparse en bloques similares para simplificar la evaluación de talento joven. Por ejemplo, DRIBBLING, BALL_CONTROL y CURVE reflejan capacidades técnicas relacionadas, mientras que VISION, POSITIONING y SHORT_PASSING representan comprensión táctica y participación ofensiva. Esto permitiría reducir la cantidad de métricas que un scout necesita revisar individualmente y enfocarse en atributos clave representativos de cada bloque, haciendo más eficiente la identificación de jugadores con mayor margen de desarrollo.</a:t>
             </a:r>
           </a:p>
         </p:txBody>
@@ -3495,7 +3479,7 @@
                 </a:solidFill>
                 <a:latin typeface="Aptos"/>
               </a:rPr>
-              <a:t>Analisis 06: Que tan cerrados son los partidos?</a:t>
+              <a:t>Analisis 06: ¿Qué tan cerrados son los partidos?</a:t>
             </a:r>
           </a:p>
         </p:txBody>
@@ -3580,7 +3564,7 @@
                 </a:solidFill>
                 <a:latin typeface="Aptos"/>
               </a:rPr>
-              <a:t>Lectura del analisis 06: Que tan cerrados son los partidos?</a:t>
+              <a:t>Lectura del análisis 06: ¿Qué tan cerrados son los partidos?</a:t>
             </a:r>
           </a:p>
         </p:txBody>
@@ -3619,7 +3603,7 @@
                 </a:solidFill>
                 <a:latin typeface="Aptos"/>
               </a:rPr>
-              <a:t>En el gráfico de anillo se observa que la categoría más frecuente es la de partidos Cerrados, es decir, aquellos definidos por 1 gol de diferencia, con 9,598 partidos, equivalentes a aproximadamente 37.0% del total. Además, si se suman los Empates y los partidos Cerrados, se obtiene alrededor de 62.3% de todos los encuentros. Esto indica que la mayor parte de los partidos del dataset se mueve en márgenes pequeños y competitivos.</a:t>
+              <a:t>La mayor parte de los partidos del dataset se define por márgenes pequeños. Los encuentros cerrados, decididos por un solo gol, representan la categoría más frecuente con cerca del 37% del total, y al sumarlos con los empates, más del 60% de los partidos terminan con diferencias mínimas. Esto confirma que los resultados suelen ser altamente competitivos y que los partidos dominados ampliamente son mucho menos comunes. En contraste, los encuentros con diferencias de 3 o más goles representan la proporción más baja del análisis.</a:t>
             </a:r>
           </a:p>
           <a:p>
@@ -3635,23 +3619,7 @@
                 </a:solidFill>
                 <a:latin typeface="Aptos"/>
               </a:rPr>
-              <a:t>Por otro lado, los partidos Moderados, definidos por 2 goles de diferencia, representan cerca de 22.1%, mientras que los partidos Amplios, con 3 o más goles de diferencia, son los menos frecuentes con aproximadamente 15.6%. Esto sugiere que los resultados abultados existen, pero son claramente menos comunes que los partidos ajustados.</a:t>
-            </a:r>
-          </a:p>
-          <a:p>
-            <a:pPr>
-              <a:spcAft>
-                <a:spcPts val="1000"/>
-              </a:spcAft>
-            </a:pPr>
-            <a:r>
-              <a:rPr sz="1800">
-                <a:solidFill>
-                  <a:srgbClr val="1F2937"/>
-                </a:solidFill>
-                <a:latin typeface="Aptos"/>
-              </a:rPr>
-              <a:t>En conjunto, el gráfico respalda la idea de que la mayoría de los partidos suelen ser cerrados. Desde una perspectiva de análisis deportivo, esto sugiere que pequeñas diferencias de rendimiento, decisiones tácticas o momentos puntuales del juego pueden tener un impacto grande en el resultado final, porque los márgenes amplios no son la norma sino la excepción.</a:t>
+              <a:t>Desde una perspectiva táctica y de scouting, este resultado sugiere que pequeñas ventajas competitivas pueden tener un impacto decisivo en el resultado final. Factores como la toma de decisiones, la concentración, la efectividad en jugadas puntuales o la capacidad para sostener ventajas mínimas adquieren más valor que simplemente generar grandes diferencias estadísticas. Para equipos y analistas, esto implica que conviene priorizar jugadores y esquemas tácticos capaces de influir en momentos clave del partido, ya que en contextos tan cerrados los detalles terminan definiendo gran parte de los resultados.</a:t>
             </a:r>
           </a:p>
         </p:txBody>
@@ -3712,7 +3680,7 @@
                 </a:solidFill>
                 <a:latin typeface="Aptos"/>
               </a:rPr>
-              <a:t>Analisis 07: En que destacan las altas promesas?</a:t>
+              <a:t>Analisis 07: ¿En qué destacan las altas promesas?</a:t>
             </a:r>
           </a:p>
         </p:txBody>
@@ -3797,7 +3765,7 @@
                 </a:solidFill>
                 <a:latin typeface="Aptos"/>
               </a:rPr>
-              <a:t>Lectura del analisis 07: En que destacan las altas promesas?</a:t>
+              <a:t>Lectura del análisis 07: ¿En qué destacan las altas promesas?</a:t>
             </a:r>
           </a:p>
         </p:txBody>
@@ -3929,7 +3897,7 @@
                 </a:solidFill>
                 <a:latin typeface="Aptos"/>
               </a:rPr>
-              <a:t>Analisis 08: A que edad rinden mejor los jugadores?</a:t>
+              <a:t>Analisis 08: ¿A qué edad rinden mejor los jugadores?</a:t>
             </a:r>
           </a:p>
         </p:txBody>
@@ -4014,7 +3982,7 @@
                 </a:solidFill>
                 <a:latin typeface="Aptos"/>
               </a:rPr>
-              <a:t>Lectura del analisis 08: A que edad rinden mejor los jugadores?</a:t>
+              <a:t>Lectura del análisis 08: ¿A qué edad rinden mejor los jugadores?</a:t>
             </a:r>
           </a:p>
         </p:txBody>
@@ -4053,7 +4021,7 @@
                 </a:solidFill>
                 <a:latin typeface="Aptos"/>
               </a:rPr>
-              <a:t>Al observar la curva de tendencia en este gráfico de líneas, podemos identificar con claridad las tres etapas biológicas y deportivas que definen la carrera de un futbolista profesional:</a:t>
+              <a:t>De este gráfico de líneas, podemos identificar cuatro etapas que definen la carrera de un futbolista profesional:</a:t>
             </a:r>
           </a:p>
           <a:p>
@@ -4079,7 +4047,7 @@
                 </a:solidFill>
                 <a:latin typeface="Aptos"/>
               </a:rPr>
-              <a:t>- El "prime" o pico de rendimiento: la curva alcanza su punto más alto y forma una "meseta" típica entre los 27 y los 31 años. Es en esta franja donde el jugador encuentra el balance perfecto: combina su máxima experiencia futbolística con un físico aún en óptimas condiciones.</a:t>
+              <a:t>- El "prime" o pico de rendimiento: la curva alcanza uno de sus puntos más altos y forma una "meseta" típica entre los 27 y los 31 años. Es en esta franja donde el jugador encuentra el balance perfecto: combina su máxima experiencia futbolística con un físico aún en óptimas condiciones.</a:t>
             </a:r>
             <a:br/>
             <a:r>
@@ -4090,6 +4058,16 @@
                 <a:latin typeface="Aptos"/>
               </a:rPr>
               <a:t>- Fase de declive: a partir de los 32 años, la línea comienza un descenso evidente, reflejando la pérdida natural de capacidades físicas, como velocidad, explosividad o resistencia, que termina por afectar la valoración general.</a:t>
+            </a:r>
+            <a:br/>
+            <a:r>
+              <a:rPr sz="1800">
+                <a:solidFill>
+                  <a:srgbClr val="1F2937"/>
+                </a:solidFill>
+                <a:latin typeface="Aptos"/>
+              </a:rPr>
+              <a:t>- Outliers: El ascenso abrupto en jugadores de 35+ puede deberse a outliers. En este ambito hay que investigar más a fondo, pues puede ser que el promedio suba debido a que los jugadores más talentosos posponen su retiro, sesgando el resultado.</a:t>
             </a:r>
           </a:p>
           <a:p>
@@ -4105,7 +4083,7 @@
                 </a:solidFill>
                 <a:latin typeface="Aptos"/>
               </a:rPr>
-              <a:t>Este gráfico dicta la lógica financiera y deportiva para armar una plantilla equilibrada. Si el equipo busca éxito inmediato para competir por un campeonato, debe apostar por jugadores en su "prime" (27-30 años), sabiendo que su costo será el más elevado. En cambio, si la directiva busca construir un proyecto a mediano plazo y generar plusvalía, la inversión debe ir hacia la fase de crecimiento (20-23 años), adquiriendo talento cuyo rendimiento y valor de mercado estadísticamente irán al alza.</a:t>
+              <a:t>Si el equipo busca éxito inmediato para competir por un campeonato, debe apostar por jugadores en su "prime" (27-30 años), sabiendo que su costo será el más elevado. En cambio, si la directiva busca construir un proyecto a mediano plazo y generar plusvalía, la inversión debe ir hacia la fase de crecimiento (20-23 años), adquiriendo talento cuyo rendimiento y valor de mercado estadísticamente irán al alza.</a:t>
             </a:r>
           </a:p>
         </p:txBody>
@@ -4166,7 +4144,7 @@
                 </a:solidFill>
                 <a:latin typeface="Aptos"/>
               </a:rPr>
-              <a:t>Analisis 09: Que formaciones equilibran uso y rendimiento?</a:t>
+              <a:t>Analisis 09: ¿Qué formaciones equilibran uso y rendimiento?</a:t>
             </a:r>
           </a:p>
         </p:txBody>
@@ -4251,7 +4229,7 @@
                 </a:solidFill>
                 <a:latin typeface="Aptos"/>
               </a:rPr>
-              <a:t>Lectura del analisis 09: Que formaciones equilibran uso y rendimiento?</a:t>
+              <a:t>Lectura del análisis 09: ¿Qué formaciones equilibran uso y rendimiento?</a:t>
             </a:r>
           </a:p>
         </p:txBody>
@@ -4383,7 +4361,7 @@
                 </a:solidFill>
                 <a:latin typeface="Aptos"/>
               </a:rPr>
-              <a:t>Analisis 01: Que atributos mirar en jugadores de campo?</a:t>
+              <a:t>Analisis 01: ¿Qué atributos mirar en jugadores de campo?</a:t>
             </a:r>
           </a:p>
         </p:txBody>
@@ -4468,7 +4446,7 @@
                 </a:solidFill>
                 <a:latin typeface="Aptos"/>
               </a:rPr>
-              <a:t>Analisis 10: Que formaciones son mas seguras o mas riesgosas?</a:t>
+              <a:t>Analisis 10: ¿Qué formaciones son más seguras o más riesgosas?</a:t>
             </a:r>
           </a:p>
         </p:txBody>
@@ -4553,7 +4531,7 @@
                 </a:solidFill>
                 <a:latin typeface="Aptos"/>
               </a:rPr>
-              <a:t>Lectura del analisis 10: Que formaciones son mas seguras o mas riesgosas?</a:t>
+              <a:t>Lectura del análisis 10: ¿Qué formaciones son más seguras o más riesgosas?</a:t>
             </a:r>
           </a:p>
         </p:txBody>
@@ -4592,7 +4570,7 @@
                 </a:solidFill>
                 <a:latin typeface="Aptos"/>
               </a:rPr>
-              <a:t>Al ver los resultados, se nota que no todas las formaciones se comportan igual en la cancha. Hay algunas que son más confiables: no siempre ganan, pero pierden poco y te mantienen compitiendo partido a partido, lo cual es clave en torneos largos. Otras son más arriesgadas: te pueden dar muchas victorias, pero también más derrotas, como si el equipo jugara al límite; estas pueden ser útiles cuando necesitas ir por todo, por ejemplo en partidos decisivos.</a:t>
+              <a:t>Desde una perspectiva táctica, el gráfico sugiere que las formaciones pueden clasificarse según su perfil de riesgo: esquemas agresivos para contextos donde ganar es prioritario, y esquemas más sólidos para torneos largos o partidos donde minimizar derrotas es más importante. Tanto para entrenadores como analistas, esto permite evaluar formaciones no solo por porcentaje de victorias, sino por la distribución completa de resultados. Así, una formación con menos derrotas y más empates puede ser más valiosa en ciertos contextos competitivos que otra con más victorias, pero también con mayor inestabilidad en sus resultados.</a:t>
             </a:r>
           </a:p>
           <a:p>
@@ -4608,7 +4586,7 @@
                 </a:solidFill>
                 <a:latin typeface="Aptos"/>
               </a:rPr>
-              <a:t>También están las formaciones más conservadoras, que tienden a empatar mucho: no arriesgan demasiado, pero tampoco marcan tanta diferencia. Para un entrenador, esto se traduce en elegir la formación no solo por estilo, sino por el momento: usar esquemas más sólidos cuando buscas regularidad y control, y formaciones más agresivas cuando necesitas ganar sí o sí, aunque implique asumir más riesgo.</a:t>
+              <a:t>Este análisis es una interpretación más “superficial” ya que la cantidad de formaciones analizadas no se toma en cuenta. Esto sesga los resultados y hace que algunas formaciones (como la 3-2-3-2) parezcan aparentemente más efectivas, pero esto se debe a que su muestra es más reducida. A diferencia de la diapositiva anterior donde se consideran muestras más amplias y con mejor representación, por lo que sus conclusiones pueden ser más definitivas y tener un mejor enfoque de comparación.</a:t>
             </a:r>
           </a:p>
         </p:txBody>
@@ -4817,7 +4795,7 @@
                 </a:solidFill>
                 <a:latin typeface="Aptos"/>
               </a:rPr>
-              <a:t>Lectura del analisis 01: Que atributos mirar en jugadores de campo?</a:t>
+              <a:t>Lectura del análisis 01: ¿Qué atributos mirar en jugadores de campo?</a:t>
             </a:r>
           </a:p>
         </p:txBody>
@@ -4856,7 +4834,7 @@
                 </a:solidFill>
                 <a:latin typeface="Aptos"/>
               </a:rPr>
-              <a:t>En el heatmap de jugadores de campo se observan bloques claros de atributos que se mueven casi juntos. Por ejemplo, ACCELERATION y SPRINT_SPEED tienen una correlación muy alta (0.89), lo que sugiere que ambas variables describen casi la misma dimensión de rapidez. Algo parecido ocurre con INTERCEPTIONS y STANDING_TACKLE (0.89), que representan un perfil defensivo muy similar.</a:t>
+              <a:t>¿Qué problema intentamos resolver con nuestro análisis?</a:t>
             </a:r>
           </a:p>
           <a:p>
@@ -4872,7 +4850,7 @@
                 </a:solidFill>
                 <a:latin typeface="Aptos"/>
               </a:rPr>
-              <a:t>También aparece un bloque técnico-ofensivo bastante marcado. DRIBBLING y BALL_CONTROL tienen una correlación alta (0.85), mientras que SHORT_PASSING y LONG_PASSING también se relacionan fuertemente (0.80). Además, FINISHING y POSITIONING muestran una correlación importante (0.80), lo que indica que los jugadores que suelen ubicarse mejor en zonas de ataque también tienden a definir mejor.</a:t>
+              <a:t>El scouting tradicional pierde tiempo evaluando decenas de atributos por jugador. Esto genera exceso de información y retrasa la toma de decisiones durante las ventanas de fichajes.</a:t>
             </a:r>
           </a:p>
           <a:p>
@@ -4888,7 +4866,55 @@
                 </a:solidFill>
                 <a:latin typeface="Aptos"/>
               </a:rPr>
-              <a:t>A nivel general, OVERALL_RATING se relaciona bastante con POTENTIAL (0.81) y con REACTIONS (0.78). Esto sugiere que la valoración global del jugador no depende de un solo atributo aislado, sino de combinaciones de técnica, lectura de juego y capacidad física. En otras palabras, para scouting de jugadores de campo no conviene tratar todas estas variables como independientes, porque varias son parcialmente redundantes y pueden resumirse por bloques.</a:t>
+              <a:t>Solución propuesta:</a:t>
+            </a:r>
+          </a:p>
+          <a:p>
+            <a:pPr>
+              <a:spcAft>
+                <a:spcPts val="1000"/>
+              </a:spcAft>
+            </a:pPr>
+            <a:r>
+              <a:rPr sz="1800">
+                <a:solidFill>
+                  <a:srgbClr val="1F2937"/>
+                </a:solidFill>
+                <a:latin typeface="Aptos"/>
+              </a:rPr>
+              <a:t>La matriz de correlación demuestra matemáticamente que los atributos se agrupan en "bloques". Por ejemplo, Velocidad y Aceleración son prácticamente el mismo dato (0.89 de similitud), al igual que Regate y Control de Balón (0.85). No necesitamos analizar 20 variables independientes.</a:t>
+            </a:r>
+          </a:p>
+          <a:p>
+            <a:pPr>
+              <a:spcAft>
+                <a:spcPts val="1000"/>
+              </a:spcAft>
+            </a:pPr>
+            <a:r>
+              <a:rPr sz="1800">
+                <a:solidFill>
+                  <a:srgbClr val="1F2937"/>
+                </a:solidFill>
+                <a:latin typeface="Aptos"/>
+              </a:rPr>
+              <a:t>Implicación del negocio:</a:t>
+            </a:r>
+          </a:p>
+          <a:p>
+            <a:pPr>
+              <a:spcAft>
+                <a:spcPts val="1000"/>
+              </a:spcAft>
+            </a:pPr>
+            <a:r>
+              <a:rPr sz="1800">
+                <a:solidFill>
+                  <a:srgbClr val="1F2937"/>
+                </a:solidFill>
+                <a:latin typeface="Aptos"/>
+              </a:rPr>
+              <a:t>Esto nos permite reducir a la mitad los indicadores clave de rendimiento (KPIs) Podemos crear un filtro automatizado mucho más ágil. En lugar de buscar "el jugador perfecto en 20 atributos", el equipo de scouting puede enfocarse en evaluar 4 o 5 "bloques o perfiles" fundamentales. Esto acelera el descarte de jugadores que no encajan en el club, optimiza las horas de trabajo de los visores y reduce el riesgo económico en los fichajes.</a:t>
             </a:r>
           </a:p>
         </p:txBody>
@@ -4949,7 +4975,7 @@
                 </a:solidFill>
                 <a:latin typeface="Aptos"/>
               </a:rPr>
-              <a:t>Analisis 02: Que atributos mirar en porteros?</a:t>
+              <a:t>Analisis 02: ¿Qué atributos mirar en porteros?</a:t>
             </a:r>
           </a:p>
         </p:txBody>
@@ -5034,7 +5060,7 @@
                 </a:solidFill>
                 <a:latin typeface="Aptos"/>
               </a:rPr>
-              <a:t>Lectura del analisis 02: Que atributos mirar en porteros?</a:t>
+              <a:t>Lectura del análisis 02: ¿Qué atributos mirar en porteros?</a:t>
             </a:r>
           </a:p>
         </p:txBody>
@@ -5073,7 +5099,7 @@
                 </a:solidFill>
                 <a:latin typeface="Aptos"/>
               </a:rPr>
-              <a:t>En el heatmap de porteros se observa una estructura mucho más concentrada que en jugadores de campo. La variable OVERALL_RATING está fuertemente relacionada con casi todos los atributos específicos de arquero, en especial con GK_MEAN (0.98), GK_DIVING (0.91), GK_REFLEXES (0.90), GK_POSITIONING (0.89) y GK_HANDLING (0.88). Esto indica que el rendimiento general del portero está muy dominado por sus habilidades técnicas propias del puesto.</a:t>
+              <a:t>¿Qué problema intentamos solucionar con nuestro análisis?</a:t>
             </a:r>
           </a:p>
           <a:p>
@@ -5089,7 +5115,7 @@
                 </a:solidFill>
                 <a:latin typeface="Aptos"/>
               </a:rPr>
-              <a:t>También se ven relaciones altas entre atributos internos del arco. Por ejemplo, GK_DIVING y GK_REFLEXES tienen una correlación de 0.89, mientras que GK_POSITIONING y GK_HANDLING alcanzan 0.83. Esto sugiere que varios indicadores del portero miden casi la misma calidad subyacente, por lo que existe bastante redundancia entre ellos.</a:t>
+              <a:t>La evaluación de porteros suele basarse en una sobrecarga de métricas redundantes, lo que ralentiza la identificación de talento y encarece la adquisición de datos y herramientas de scouting.</a:t>
             </a:r>
           </a:p>
           <a:p>
@@ -5105,7 +5131,7 @@
                 </a:solidFill>
                 <a:latin typeface="Aptos"/>
               </a:rPr>
-              <a:t>En cambio, JUMPING muestra una relación bastante menor con el bloque principal de variables de arquero. Por ejemplo, su correlación con GK_MEAN es solo de 0.40. Esto sugiere que el salto aporta información complementaria, pero no explica tanto el nivel global del portero como las habilidades técnicas de atajada, colocación y reflejos.</a:t>
+              <a:t>¿Qué solución se propone?</a:t>
             </a:r>
           </a:p>
           <a:p>
@@ -5121,7 +5147,39 @@
                 </a:solidFill>
                 <a:latin typeface="Aptos"/>
               </a:rPr>
-              <a:t>En conjunto, este gráfico sugiere que para evaluar porteros se puede resumir gran parte del perfil usando pocas variables clave, porque muchas de las métricas del puesto se mueven casi juntas. A diferencia de los jugadores de campo, aquí la redundancia es más fuerte y el perfil parece estar más concentrado en un solo bloque de rendimiento especializado.</a:t>
+              <a:t>Habilidades como Estirada (Diving) y Reflejos (0.89), o Colocación (Positioning) y Manejo (Handling) (0.83), son indivisibles. En la práctica, un portero que sabe ubicarse raramente da rebotes peligrosos. El entrenamiento y el scouting deben evaluar estos pares de forma conjunta, no aislada. Se detecta una variable aislada, el salto (Jumping) nos indica que la calidad de un portero se centra más en técnica y ubicación, no en atletismo puro.</a:t>
+            </a:r>
+          </a:p>
+          <a:p>
+            <a:pPr>
+              <a:spcAft>
+                <a:spcPts val="1000"/>
+              </a:spcAft>
+            </a:pPr>
+            <a:r>
+              <a:rPr sz="1800">
+                <a:solidFill>
+                  <a:srgbClr val="1F2937"/>
+                </a:solidFill>
+                <a:latin typeface="Aptos"/>
+              </a:rPr>
+              <a:t>¿Qué utilidad trae al negocio el análisis?</a:t>
+            </a:r>
+          </a:p>
+          <a:p>
+            <a:pPr>
+              <a:spcAft>
+                <a:spcPts val="1000"/>
+              </a:spcAft>
+            </a:pPr>
+            <a:r>
+              <a:rPr sz="1800">
+                <a:solidFill>
+                  <a:srgbClr val="1F2937"/>
+                </a:solidFill>
+                <a:latin typeface="Aptos"/>
+              </a:rPr>
+              <a:t>Hacer que auditar 15 atributos distintos por portero no sea necesario da un incremento significativo en el ahorro de tiempo y dinero. El sistema de scouting se puede automatizar con solo 2 o 3 métricas clave, ahorrando cientos de horas de análisis de video y datos, asimismo ayuda a identificar “gangas” en el mercado. Al saber que el rendimiento general el predecible se pueden filtrar bases de datos en segundos para encontrar porteros de ligas menores con el mismo perfil estadístico que opciones mucho más caras.</a:t>
             </a:r>
           </a:p>
         </p:txBody>
@@ -5182,7 +5240,7 @@
                 </a:solidFill>
                 <a:latin typeface="Aptos"/>
               </a:rPr>
-              <a:t>Analisis 03: Cuanto margen tienen los campistas jovenes?</a:t>
+              <a:t>Analisis 03: ¿Cuánto margen tienen los campistas jovenes?</a:t>
             </a:r>
           </a:p>
         </p:txBody>
@@ -5267,7 +5325,7 @@
                 </a:solidFill>
                 <a:latin typeface="Aptos"/>
               </a:rPr>
-              <a:t>Lectura del analisis 03: Cuanto margen tienen los campistas jovenes?</a:t>
+              <a:t>Lectura del análisis 03: ¿Cuánto margen tienen los campistas jovenes?</a:t>
             </a:r>
           </a:p>
         </p:txBody>
@@ -5306,7 +5364,7 @@
                 </a:solidFill>
                 <a:latin typeface="Aptos"/>
               </a:rPr>
-              <a:t>En el histograma de jugadores de campo se observa que la gran mayoría de los casos tiene un gap positivo entre POTENTIAL y OVERALL_RATING. Esto sugiere que, dentro de este grupo de jugadores jóvenes, lo normal es que todavía exista margen de desarrollo y que su nivel actual aún esté por debajo de su techo estimado.</a:t>
+              <a:t>¿Qué problema se trata en este análisis?</a:t>
             </a:r>
           </a:p>
           <a:p>
@@ -5322,7 +5380,7 @@
                 </a:solidFill>
                 <a:latin typeface="Aptos"/>
               </a:rPr>
-              <a:t>La distribución se concentra sobre todo entre valores de gap de 7 a 11, con una mediana cercana a 8. Esto indica que, para muchos jugadores de campo jóvenes, el margen de crecimiento existe, pero no suele ser extremo. Los casos con gaps muy altos también aparecen, incluso llegando a valores cercanos a 22, pero claramente son menos frecuentes y pueden interpretarse como perfiles especialmente interesantes para scouting.</a:t>
+              <a:t>Al fichar talento joven (18 – 23 años), los clubes suelen guiarse por la intuición sobre "cuánto puede mejorar" un jugador, asumiendo riesgos financieros altos sin un parámetro de lo que es un crecimiento normal frente a uno excepcional.</a:t>
             </a:r>
           </a:p>
           <a:p>
@@ -5338,7 +5396,55 @@
                 </a:solidFill>
                 <a:latin typeface="Aptos"/>
               </a:rPr>
-              <a:t>En conjunto, el gráfico sugiere que los jugadores de campo jóvenes suelen tener un margen de desarrollo moderado y relativamente estable. Por eso, al buscar prospectos, conviene prestar más atención a los casos que se alejan hacia la derecha de la distribución, ya que ahí es donde aparecen jugadores con un potencial mucho más alto que su rendimiento actual.</a:t>
+              <a:t>¿Qué solución se propone?</a:t>
+            </a:r>
+          </a:p>
+          <a:p>
+            <a:pPr>
+              <a:spcAft>
+                <a:spcPts val="1000"/>
+              </a:spcAft>
+            </a:pPr>
+            <a:r>
+              <a:rPr sz="1800">
+                <a:solidFill>
+                  <a:srgbClr val="1F2937"/>
+                </a:solidFill>
+                <a:latin typeface="Aptos"/>
+              </a:rPr>
+              <a:t>Este análisis se basa exclusivamente en un conjunto de datos de ligas de primera división europea. En base al histograma, podemos observar que el margen de crecimiento (gap) de un prospecto joven incluido en este dataset tiende a concentrarse entre los 7 y 10 puntos. Este comportamiento de la muestra define nuestro estándar de mercado.</a:t>
+            </a:r>
+          </a:p>
+          <a:p>
+            <a:pPr>
+              <a:spcAft>
+                <a:spcPts val="1000"/>
+              </a:spcAft>
+            </a:pPr>
+            <a:r>
+              <a:rPr sz="1800">
+                <a:solidFill>
+                  <a:srgbClr val="1F2937"/>
+                </a:solidFill>
+                <a:latin typeface="Aptos"/>
+              </a:rPr>
+              <a:t>¿Qué implicaciones hay para el negocio?</a:t>
+            </a:r>
+          </a:p>
+          <a:p>
+            <a:pPr>
+              <a:spcAft>
+                <a:spcPts val="1000"/>
+              </a:spcAft>
+            </a:pPr>
+            <a:r>
+              <a:rPr sz="1800">
+                <a:solidFill>
+                  <a:srgbClr val="1F2937"/>
+                </a:solidFill>
+                <a:latin typeface="Aptos"/>
+              </a:rPr>
+              <a:t>El departamento de scouting debe prestar menos atención al centro de la gráfica y enfocarse exclusivamente en la "cola derecha" (prospectos con un gap mayor a 12-14 puntos). Estos son los "activos infravalorados": jugadores cuyo costo de transferencia actual es bajo porque su rendimiento inmediato no refleja su techo real. Aquí es donde el club puede comprar barato y vender caro.</a:t>
             </a:r>
           </a:p>
         </p:txBody>
@@ -5399,7 +5505,7 @@
                 </a:solidFill>
                 <a:latin typeface="Aptos"/>
               </a:rPr>
-              <a:t>Analisis 04: Cuanto margen tienen los porteros jovenes?</a:t>
+              <a:t>Analisis 04: ¿Cuánto margen tienen los porteros jovenes?</a:t>
             </a:r>
           </a:p>
         </p:txBody>
@@ -5484,7 +5590,7 @@
                 </a:solidFill>
                 <a:latin typeface="Aptos"/>
               </a:rPr>
-              <a:t>Lectura del analisis 04: Cuanto margen tienen los porteros jovenes?</a:t>
+              <a:t>Lectura del análisis 04: ¿Cuánto margen tienen los porteros jovenes?</a:t>
             </a:r>
           </a:p>
         </p:txBody>
@@ -5523,7 +5629,7 @@
                 </a:solidFill>
                 <a:latin typeface="Aptos"/>
               </a:rPr>
-              <a:t>En el histograma de porteros también se observa una distribución claramente desplazada hacia valores positivos de gap. Esto sugiere que los arqueros jóvenes del dataset, al igual que los jugadores de campo, suelen conservar margen de desarrollo entre su POTENTIAL y su OVERALL_RATING.</a:t>
+              <a:t>¿Qué problema se aborda en este análisis?</a:t>
             </a:r>
           </a:p>
           <a:p>
@@ -5539,7 +5645,7 @@
                 </a:solidFill>
                 <a:latin typeface="Aptos"/>
               </a:rPr>
-              <a:t>En este caso, la distribución se concentra principalmente entre 7 y 12, con una mediana cercana a 9. Esto sugiere un margen de crecimiento ligeramente mayor que el observado en jugadores de campo. Sin embargo, aquí el número de observaciones es bastante menor, por lo que conviene interpretar el patrón con más cuidado y no sacar conclusiones demasiado fuertes a partir de pequeñas diferencias.</a:t>
+              <a:t>Evaluar el talento y el techo de los porteros jóvenes (18-23 años) es uno de los mayores retos en el mercado, ya que su curva de maduración suele diferir de la del resto del equipo. Asumir riesgos financieros basándose solo en la intuición puede resultar en inversiones estancadas.</a:t>
             </a:r>
           </a:p>
           <a:p>
@@ -5555,7 +5661,55 @@
                 </a:solidFill>
                 <a:latin typeface="Aptos"/>
               </a:rPr>
-              <a:t>En conjunto, el gráfico indica que los porteros jóvenes también presentan espacio para mejorar, pero el análisis debe leerse con más prudencia por el tamaño de muestra. Aun así, los casos ubicados hacia la derecha de la distribución pueden verse como porteros especialmente prometedores, ya que combinan un nivel actual todavía contenido con un techo estimado más alto.</a:t>
+              <a:t>¿Qué solución se presenta?</a:t>
+            </a:r>
+          </a:p>
+          <a:p>
+            <a:pPr>
+              <a:spcAft>
+                <a:spcPts val="1000"/>
+              </a:spcAft>
+            </a:pPr>
+            <a:r>
+              <a:rPr sz="1800">
+                <a:solidFill>
+                  <a:srgbClr val="1F2937"/>
+                </a:solidFill>
+                <a:latin typeface="Aptos"/>
+              </a:rPr>
+              <a:t>Este análisis se basa exclusivamente en un conjunto de datos de ligas de primera división europea. En base al histograma, podemos observar que el margen de crecimiento (gap) de los arqueros jóvenes incluidos en este dataset tiende a concentrarse principalmente entre los 7 y 12 puntos, con una mediana cercana a 9. Este comportamiento observado en la muestra define nuestro estándar de mercado para la posición.</a:t>
+            </a:r>
+          </a:p>
+          <a:p>
+            <a:pPr>
+              <a:spcAft>
+                <a:spcPts val="1000"/>
+              </a:spcAft>
+            </a:pPr>
+            <a:r>
+              <a:rPr sz="1800">
+                <a:solidFill>
+                  <a:srgbClr val="1F2937"/>
+                </a:solidFill>
+                <a:latin typeface="Aptos"/>
+              </a:rPr>
+              <a:t>¿Qué implicaciones tiene para el negocio?</a:t>
+            </a:r>
+          </a:p>
+          <a:p>
+            <a:pPr>
+              <a:spcAft>
+                <a:spcPts val="1000"/>
+              </a:spcAft>
+            </a:pPr>
+            <a:r>
+              <a:rPr sz="1800">
+                <a:solidFill>
+                  <a:srgbClr val="1F2937"/>
+                </a:solidFill>
+                <a:latin typeface="Aptos"/>
+              </a:rPr>
+              <a:t>El departamento de scouting debe enfocar sus recursos en la "cola derecha" de la distribución. Estos casos atípicos representan arqueros que combinan un nivel actual todavía contenido con un techo estimado mucho más alto. Identificarlos permite adquirir prospectos prometedores a un costo de transferencia inicial bajo, maximizando la plusvalía a largo plazo.</a:t>
             </a:r>
           </a:p>
         </p:txBody>

</xml_diff>

<commit_message>
Final version of the project
</commit_message>
<xml_diff>
--- a/OUTPUTS/presentacion_final.pptx
+++ b/OUTPUTS/presentacion_final.pptx
@@ -27,6 +27,8 @@
     <p:sldId id="275" r:id="rId26"/>
     <p:sldId id="276" r:id="rId27"/>
     <p:sldId id="277" r:id="rId28"/>
+    <p:sldId id="278" r:id="rId29"/>
+    <p:sldId id="279" r:id="rId30"/>
   </p:sldIdLst>
   <p:sldSz cx="12188952" cy="6858000" type="screen4x3"/>
   <p:notesSz cx="6858000" cy="9144000"/>
@@ -3141,13 +3143,13 @@
           <a:p>
             <a:pPr algn="l"/>
             <a:r>
-              <a:rPr sz="2400" b="1">
+              <a:rPr sz="3000" b="1">
                 <a:solidFill>
                   <a:srgbClr val="1D4E89"/>
                 </a:solidFill>
                 <a:latin typeface="Aptos"/>
               </a:rPr>
-              <a:t>Analisis de datos para decisiones futbolisticas</a:t>
+              <a:t>Análisis de datos para decisiones futbolisticas</a:t>
             </a:r>
           </a:p>
         </p:txBody>
@@ -3160,8 +3162,8 @@
         </p:nvSpPr>
         <p:spPr>
           <a:xfrm>
-            <a:off x="822960" y="2194560"/>
-            <a:ext cx="9875520" cy="731520"/>
+            <a:off x="822960" y="1828800"/>
+            <a:ext cx="9601200" cy="914400"/>
           </a:xfrm>
           <a:prstGeom prst="rect">
             <a:avLst/>
@@ -3176,13 +3178,13 @@
           <a:p>
             <a:pPr algn="l"/>
             <a:r>
-              <a:rPr sz="1500" b="0">
+              <a:rPr sz="1800" b="0">
                 <a:solidFill>
                   <a:srgbClr val="8D99AE"/>
                 </a:solidFill>
                 <a:latin typeface="Aptos"/>
               </a:rPr>
-              <a:t>Scouting, perfiles de jugador, valor competitivo y apoyo a decisiones tacticas</a:t>
+              <a:t>Scouting, perfiles de jugador, valor competitivo y apoyo a decisiones tácticas</a:t>
             </a:r>
           </a:p>
         </p:txBody>
@@ -3196,7 +3198,7 @@
         <p:spPr>
           <a:xfrm>
             <a:off x="822960" y="3931920"/>
-            <a:ext cx="9601200" cy="1097280"/>
+            <a:ext cx="9601200" cy="914400"/>
           </a:xfrm>
           <a:prstGeom prst="rect">
             <a:avLst/>
@@ -3211,13 +3213,13 @@
           <a:p>
             <a:pPr algn="l"/>
             <a:r>
-              <a:rPr sz="1800" b="0">
-                <a:solidFill>
-                  <a:srgbClr val="1F2937"/>
-                </a:solidFill>
-                <a:latin typeface="Aptos"/>
-              </a:rPr>
-              <a:t>Presentacion con graficas e interpretaciones del analisis.</a:t>
+              <a:rPr sz="2200" b="0">
+                <a:solidFill>
+                  <a:srgbClr val="1F2937"/>
+                </a:solidFill>
+                <a:latin typeface="Aptos"/>
+              </a:rPr>
+              <a:t>Presentación con gráficas e interpretaciones del análisis.</a:t>
             </a:r>
           </a:p>
         </p:txBody>
@@ -3278,7 +3280,7 @@
                 </a:solidFill>
                 <a:latin typeface="Aptos"/>
               </a:rPr>
-              <a:t>Analisis 05: ¿Qué distingue a los jovenes con alto potencial?</a:t>
+              <a:t>Analisis 04: ¿Cuánto margen tienen los porteros jovenes?</a:t>
             </a:r>
           </a:p>
         </p:txBody>
@@ -3299,8 +3301,8 @@
         </p:blipFill>
         <p:spPr>
           <a:xfrm>
-            <a:off x="2416628" y="1188720"/>
-            <a:ext cx="7053942" cy="4937760"/>
+            <a:off x="1005839" y="1188720"/>
+            <a:ext cx="9875520" cy="4937760"/>
           </a:xfrm>
           <a:prstGeom prst="rect">
             <a:avLst/>
@@ -3363,7 +3365,7 @@
                 </a:solidFill>
                 <a:latin typeface="Aptos"/>
               </a:rPr>
-              <a:t>Lectura del análisis 05: ¿Qué distingue a los jovenes con alto potencial?</a:t>
+              <a:t>Lectura del análisis 04: ¿Cuánto margen tienen los porteros jovenes?</a:t>
             </a:r>
           </a:p>
         </p:txBody>
@@ -3402,7 +3404,7 @@
                 </a:solidFill>
                 <a:latin typeface="Aptos"/>
               </a:rPr>
-              <a:t>Los jugadores jóvenes con mayor potencial destacan principalmente por atributos técnicos y ofensivos, más que por capacidades físicas o defensivas. DRIBBLING, CURVE, BALL_CONTROL y LONG_SHOTS son las variables con mayor diferencia respecto al grupo de referencia, lo que sugiere que el principal desarrollo está más asociado con calidad técnica, creatividad y capacidad para generar jugadas ofensivas que con atributos defensivos tradicionales. También sobresalen POSITIONING y VISION, indicando que la lectura de juego y la toma de decisiones son factores importantes en perfiles con alto potencial.</a:t>
+              <a:t>¿Qué problema se aborda en este análisis?</a:t>
             </a:r>
           </a:p>
           <a:p>
@@ -3418,7 +3420,71 @@
                 </a:solidFill>
                 <a:latin typeface="Aptos"/>
               </a:rPr>
-              <a:t>Desde la perspectiva de scouting, el gráfico sugiere que varios atributos pueden agruparse en bloques similares para simplificar la evaluación de talento joven. Por ejemplo, DRIBBLING, BALL_CONTROL y CURVE reflejan capacidades técnicas relacionadas, mientras que VISION, POSITIONING y SHORT_PASSING representan comprensión táctica y participación ofensiva. Esto permitiría reducir la cantidad de métricas que un scout necesita revisar individualmente y enfocarse en atributos clave representativos de cada bloque, haciendo más eficiente la identificación de jugadores con mayor margen de desarrollo.</a:t>
+              <a:t>Evaluar el talento y el techo de los porteros jóvenes (18-23 años) es uno de los mayores retos en el mercado, ya que su curva de maduración suele diferir de la del resto del equipo. Asumir riesgos financieros basándose solo en la intuición puede resultar en inversiones estancadas.</a:t>
+            </a:r>
+          </a:p>
+          <a:p>
+            <a:pPr>
+              <a:spcAft>
+                <a:spcPts val="1000"/>
+              </a:spcAft>
+            </a:pPr>
+            <a:r>
+              <a:rPr sz="1800">
+                <a:solidFill>
+                  <a:srgbClr val="1F2937"/>
+                </a:solidFill>
+                <a:latin typeface="Aptos"/>
+              </a:rPr>
+              <a:t>¿Qué solución se presenta?</a:t>
+            </a:r>
+          </a:p>
+          <a:p>
+            <a:pPr>
+              <a:spcAft>
+                <a:spcPts val="1000"/>
+              </a:spcAft>
+            </a:pPr>
+            <a:r>
+              <a:rPr sz="1800">
+                <a:solidFill>
+                  <a:srgbClr val="1F2937"/>
+                </a:solidFill>
+                <a:latin typeface="Aptos"/>
+              </a:rPr>
+              <a:t>Este análisis se basa exclusivamente en un conjunto de datos de ligas de primera división europea. En base al histograma, podemos observar que el margen de crecimiento (gap) de los arqueros jóvenes incluidos en este dataset tiende a concentrarse principalmente entre los 7 y 12 puntos, con una mediana cercana a 9. Este comportamiento observado en la muestra define nuestro estándar de mercado para la posición.</a:t>
+            </a:r>
+          </a:p>
+          <a:p>
+            <a:pPr>
+              <a:spcAft>
+                <a:spcPts val="1000"/>
+              </a:spcAft>
+            </a:pPr>
+            <a:r>
+              <a:rPr sz="1800">
+                <a:solidFill>
+                  <a:srgbClr val="1F2937"/>
+                </a:solidFill>
+                <a:latin typeface="Aptos"/>
+              </a:rPr>
+              <a:t>¿Qué implicaciones tiene para el negocio?</a:t>
+            </a:r>
+          </a:p>
+          <a:p>
+            <a:pPr>
+              <a:spcAft>
+                <a:spcPts val="1000"/>
+              </a:spcAft>
+            </a:pPr>
+            <a:r>
+              <a:rPr sz="1800">
+                <a:solidFill>
+                  <a:srgbClr val="1F2937"/>
+                </a:solidFill>
+                <a:latin typeface="Aptos"/>
+              </a:rPr>
+              <a:t>El departamento de scouting debe enfocar sus recursos en la "cola derecha" de la distribución. Estos casos atípicos representan arqueros que combinan un nivel actual todavía contenido con un techo estimado mucho más alto. Identificarlos permite adquirir prospectos prometedores a un costo de transferencia inicial bajo, maximizando la plusvalía a largo plazo.</a:t>
             </a:r>
           </a:p>
         </p:txBody>
@@ -3479,7 +3545,7 @@
                 </a:solidFill>
                 <a:latin typeface="Aptos"/>
               </a:rPr>
-              <a:t>Analisis 06: ¿Qué tan cerrados son los partidos?</a:t>
+              <a:t>Analisis 05: ¿Qué distingue a los jovenes con alto potencial?</a:t>
             </a:r>
           </a:p>
         </p:txBody>
@@ -3500,8 +3566,8 @@
         </p:blipFill>
         <p:spPr>
           <a:xfrm>
-            <a:off x="2548889" y="1188720"/>
-            <a:ext cx="6789420" cy="4937760"/>
+            <a:off x="2416628" y="1188720"/>
+            <a:ext cx="7053942" cy="4937760"/>
           </a:xfrm>
           <a:prstGeom prst="rect">
             <a:avLst/>
@@ -3564,7 +3630,7 @@
                 </a:solidFill>
                 <a:latin typeface="Aptos"/>
               </a:rPr>
-              <a:t>Lectura del análisis 06: ¿Qué tan cerrados son los partidos?</a:t>
+              <a:t>Lectura del análisis 05: ¿Qué distingue a los jovenes con alto potencial?</a:t>
             </a:r>
           </a:p>
         </p:txBody>
@@ -3603,7 +3669,7 @@
                 </a:solidFill>
                 <a:latin typeface="Aptos"/>
               </a:rPr>
-              <a:t>La mayor parte de los partidos del dataset se define por márgenes pequeños. Los encuentros cerrados, decididos por un solo gol, representan la categoría más frecuente con cerca del 37% del total, y al sumarlos con los empates, más del 60% de los partidos terminan con diferencias mínimas. Esto confirma que los resultados suelen ser altamente competitivos y que los partidos dominados ampliamente son mucho menos comunes. En contraste, los encuentros con diferencias de 3 o más goles representan la proporción más baja del análisis.</a:t>
+              <a:t>Los jugadores jóvenes con mayor potencial destacan principalmente por atributos técnicos y ofensivos, más que por capacidades físicas o defensivas. DRIBBLING, CURVE, BALL_CONTROL y LONG_SHOTS son las variables con mayor diferencia respecto al grupo de referencia, lo que sugiere que el principal desarrollo está más asociado con calidad técnica, creatividad y capacidad para generar jugadas ofensivas que con atributos defensivos tradicionales. También sobresalen POSITIONING y VISION, indicando que la lectura de juego y la toma de decisiones son factores importantes en perfiles con alto potencial.</a:t>
             </a:r>
           </a:p>
           <a:p>
@@ -3619,7 +3685,7 @@
                 </a:solidFill>
                 <a:latin typeface="Aptos"/>
               </a:rPr>
-              <a:t>Desde una perspectiva táctica y de scouting, este resultado sugiere que pequeñas ventajas competitivas pueden tener un impacto decisivo en el resultado final. Factores como la toma de decisiones, la concentración, la efectividad en jugadas puntuales o la capacidad para sostener ventajas mínimas adquieren más valor que simplemente generar grandes diferencias estadísticas. Para equipos y analistas, esto implica que conviene priorizar jugadores y esquemas tácticos capaces de influir en momentos clave del partido, ya que en contextos tan cerrados los detalles terminan definiendo gran parte de los resultados.</a:t>
+              <a:t>Desde la perspectiva de scouting, el gráfico sugiere que varios atributos pueden agruparse en bloques similares para simplificar la evaluación de talento joven. Por ejemplo, DRIBBLING, BALL_CONTROL y CURVE reflejan capacidades técnicas relacionadas, mientras que VISION, POSITIONING y SHORT_PASSING representan comprensión táctica y participación ofensiva. Esto permitiría reducir la cantidad de métricas que un scout necesita revisar individualmente y enfocarse en atributos clave representativos de cada bloque, haciendo más eficiente la identificación de jugadores con mayor margen de desarrollo.</a:t>
             </a:r>
           </a:p>
         </p:txBody>
@@ -3680,7 +3746,7 @@
                 </a:solidFill>
                 <a:latin typeface="Aptos"/>
               </a:rPr>
-              <a:t>Analisis 07: ¿En qué destacan las altas promesas?</a:t>
+              <a:t>Analisis 06: ¿Qué tan cerrados son los partidos?</a:t>
             </a:r>
           </a:p>
         </p:txBody>
@@ -3701,8 +3767,8 @@
         </p:blipFill>
         <p:spPr>
           <a:xfrm>
-            <a:off x="1005839" y="1188720"/>
-            <a:ext cx="9875520" cy="4937760"/>
+            <a:off x="2548889" y="1188720"/>
+            <a:ext cx="6789420" cy="4937760"/>
           </a:xfrm>
           <a:prstGeom prst="rect">
             <a:avLst/>
@@ -3765,7 +3831,7 @@
                 </a:solidFill>
                 <a:latin typeface="Aptos"/>
               </a:rPr>
-              <a:t>Lectura del análisis 07: ¿En qué destacan las altas promesas?</a:t>
+              <a:t>Lectura del análisis 06: ¿Qué tan cerrados son los partidos?</a:t>
             </a:r>
           </a:p>
         </p:txBody>
@@ -3804,7 +3870,7 @@
                 </a:solidFill>
                 <a:latin typeface="Aptos"/>
               </a:rPr>
-              <a:t>El boxplot muestra que el grupo de Alta Promesa (Top 10%) presenta distribuciones más altas que el grupo de Resto de Jóvenes en los seis atributos evaluados. Esto se nota porque, en todos los casos, la mediana de las altas promesas queda por encima de la mediana del resto, lo que indica una ventaja consistente y no aislada en un solo atributo.</a:t>
+              <a:t>La mayor parte de los partidos del dataset se define por márgenes pequeños. Los encuentros cerrados, decididos por un solo gol, representan la categoría más frecuente con cerca del 37% del total, y al sumarlos con los empates, más del 60% de los partidos terminan con diferencias mínimas. Esto confirma que los resultados suelen ser altamente competitivos y que los partidos dominados ampliamente son mucho menos comunes. En contraste, los encuentros con diferencias de 3 o más goles representan la proporción más baja del análisis.</a:t>
             </a:r>
           </a:p>
           <a:p>
@@ -3820,23 +3886,7 @@
                 </a:solidFill>
                 <a:latin typeface="Aptos"/>
               </a:rPr>
-              <a:t>Las diferencias más marcadas aparecen en atributos como Visión, Control de Balón, Reacciones y Pase Corto. Esto sugiere que los jugadores jóvenes con mayor potencial no solo destacan por condiciones físicas, sino también por atributos técnicos y de lectura del juego. En Velocidad Sprint y Resistencia también se observa una ventaja para las altas promesas, aunque la separación entre grupos parece algo menor.</a:t>
-            </a:r>
-          </a:p>
-          <a:p>
-            <a:pPr>
-              <a:spcAft>
-                <a:spcPts val="1000"/>
-              </a:spcAft>
-            </a:pPr>
-            <a:r>
-              <a:rPr sz="1800">
-                <a:solidFill>
-                  <a:srgbClr val="1F2937"/>
-                </a:solidFill>
-                <a:latin typeface="Aptos"/>
-              </a:rPr>
-              <a:t>En conjunto, la gráfica sugiere que el potencial alto en jugadores jóvenes está asociado a un perfil más completo y balanceado. Es decir, las altas promesas no sobresalen solo en un atributo puntual, sino que tienden a mantener niveles superiores en varias dimensiones importantes del rendimiento.</a:t>
+              <a:t>Desde una perspectiva táctica y de scouting, este resultado sugiere que pequeñas ventajas competitivas pueden tener un impacto decisivo en el resultado final. Factores como la toma de decisiones, la concentración, la efectividad en jugadas puntuales o la capacidad para sostener ventajas mínimas adquieren más valor que simplemente generar grandes diferencias estadísticas. Para equipos y analistas, esto implica que conviene priorizar jugadores y esquemas tácticos capaces de influir en momentos clave del partido, ya que en contextos tan cerrados los detalles terminan definiendo gran parte de los resultados.</a:t>
             </a:r>
           </a:p>
         </p:txBody>
@@ -3897,7 +3947,7 @@
                 </a:solidFill>
                 <a:latin typeface="Aptos"/>
               </a:rPr>
-              <a:t>Analisis 08: ¿A qué edad rinden mejor los jugadores?</a:t>
+              <a:t>Analisis 07: ¿En qué destacan las altas promesas?</a:t>
             </a:r>
           </a:p>
         </p:txBody>
@@ -3918,8 +3968,8 @@
         </p:blipFill>
         <p:spPr>
           <a:xfrm>
-            <a:off x="1828800" y="1188720"/>
-            <a:ext cx="8229600" cy="4937760"/>
+            <a:off x="1005839" y="1188720"/>
+            <a:ext cx="9875520" cy="4937760"/>
           </a:xfrm>
           <a:prstGeom prst="rect">
             <a:avLst/>
@@ -3982,7 +4032,7 @@
                 </a:solidFill>
                 <a:latin typeface="Aptos"/>
               </a:rPr>
-              <a:t>Lectura del análisis 08: ¿A qué edad rinden mejor los jugadores?</a:t>
+              <a:t>Lectura del análisis 07: ¿En qué destacan las altas promesas?</a:t>
             </a:r>
           </a:p>
         </p:txBody>
@@ -4021,7 +4071,7 @@
                 </a:solidFill>
                 <a:latin typeface="Aptos"/>
               </a:rPr>
-              <a:t>De este gráfico de líneas, podemos identificar cuatro etapas que definen la carrera de un futbolista profesional:</a:t>
+              <a:t>El boxplot muestra que el grupo de Alta Promesa (Top 10%) presenta distribuciones más altas que el grupo de Resto de Jóvenes en los seis atributos evaluados. Esto se nota porque, en todos los casos, la mediana de las altas promesas queda por encima de la mediana del resto, lo que indica una ventaja consistente y no aislada en un solo atributo.</a:t>
             </a:r>
           </a:p>
           <a:p>
@@ -4037,37 +4087,7 @@
                 </a:solidFill>
                 <a:latin typeface="Aptos"/>
               </a:rPr>
-              <a:t>- Fase de crecimiento: desde las edades más tempranas (16-18 años), la línea muestra una pendiente ascendente constante y pronunciada. Es en esta etapa donde los jugadores adquieren madurez táctica, experiencia y desarrollo físico.</a:t>
-            </a:r>
-            <a:br/>
-            <a:r>
-              <a:rPr sz="1800">
-                <a:solidFill>
-                  <a:srgbClr val="1F2937"/>
-                </a:solidFill>
-                <a:latin typeface="Aptos"/>
-              </a:rPr>
-              <a:t>- El "prime" o pico de rendimiento: la curva alcanza uno de sus puntos más altos y forma una "meseta" típica entre los 27 y los 31 años. Es en esta franja donde el jugador encuentra el balance perfecto: combina su máxima experiencia futbolística con un físico aún en óptimas condiciones.</a:t>
-            </a:r>
-            <a:br/>
-            <a:r>
-              <a:rPr sz="1800">
-                <a:solidFill>
-                  <a:srgbClr val="1F2937"/>
-                </a:solidFill>
-                <a:latin typeface="Aptos"/>
-              </a:rPr>
-              <a:t>- Fase de declive: a partir de los 32 años, la línea comienza un descenso evidente, reflejando la pérdida natural de capacidades físicas, como velocidad, explosividad o resistencia, que termina por afectar la valoración general.</a:t>
-            </a:r>
-            <a:br/>
-            <a:r>
-              <a:rPr sz="1800">
-                <a:solidFill>
-                  <a:srgbClr val="1F2937"/>
-                </a:solidFill>
-                <a:latin typeface="Aptos"/>
-              </a:rPr>
-              <a:t>- Outliers: El ascenso abrupto en jugadores de 35+ puede deberse a outliers. En este ambito hay que investigar más a fondo, pues puede ser que el promedio suba debido a que los jugadores más talentosos posponen su retiro, sesgando el resultado.</a:t>
+              <a:t>Las diferencias más marcadas aparecen en atributos como Visión, Control de Balón, Reacciones y Pase Corto. Esto sugiere que los jugadores jóvenes con mayor potencial no solo destacan por condiciones físicas, sino también por atributos técnicos y de lectura del juego. En Velocidad Sprint y Resistencia también se observa una ventaja para las altas promesas, aunque la separación entre grupos parece algo menor.</a:t>
             </a:r>
           </a:p>
           <a:p>
@@ -4083,7 +4103,7 @@
                 </a:solidFill>
                 <a:latin typeface="Aptos"/>
               </a:rPr>
-              <a:t>Si el equipo busca éxito inmediato para competir por un campeonato, debe apostar por jugadores en su "prime" (27-30 años), sabiendo que su costo será el más elevado. En cambio, si la directiva busca construir un proyecto a mediano plazo y generar plusvalía, la inversión debe ir hacia la fase de crecimiento (20-23 años), adquiriendo talento cuyo rendimiento y valor de mercado estadísticamente irán al alza.</a:t>
+              <a:t>En conjunto, la gráfica sugiere que el potencial alto en jugadores jóvenes está asociado a un perfil más completo y balanceado. Es decir, las altas promesas no sobresalen solo en un atributo puntual, sino que tienden a mantener niveles superiores en varias dimensiones importantes del rendimiento.</a:t>
             </a:r>
           </a:p>
         </p:txBody>
@@ -4144,7 +4164,7 @@
                 </a:solidFill>
                 <a:latin typeface="Aptos"/>
               </a:rPr>
-              <a:t>Analisis 09: ¿Qué formaciones equilibran uso y rendimiento?</a:t>
+              <a:t>Analisis 08: ¿A qué edad rinden mejor los jugadores?</a:t>
             </a:r>
           </a:p>
         </p:txBody>
@@ -4165,8 +4185,8 @@
         </p:blipFill>
         <p:spPr>
           <a:xfrm>
-            <a:off x="2063931" y="1188720"/>
-            <a:ext cx="7759337" cy="4937760"/>
+            <a:off x="1828800" y="1188720"/>
+            <a:ext cx="8229600" cy="4937760"/>
           </a:xfrm>
           <a:prstGeom prst="rect">
             <a:avLst/>
@@ -4229,7 +4249,7 @@
                 </a:solidFill>
                 <a:latin typeface="Aptos"/>
               </a:rPr>
-              <a:t>Lectura del análisis 09: ¿Qué formaciones equilibran uso y rendimiento?</a:t>
+              <a:t>Lectura del análisis 08: ¿A qué edad rinden mejor los jugadores?</a:t>
             </a:r>
           </a:p>
         </p:txBody>
@@ -4268,7 +4288,7 @@
                 </a:solidFill>
                 <a:latin typeface="Aptos"/>
               </a:rPr>
-              <a:t>El bubble plot sugiere que no todas las formaciones combinan del mismo modo frecuencia de uso y rendimiento. En la zona superior derecha, donde coinciden más puntos por partido y una diferencia de gol promedio menos negativa o incluso positiva, aparecen esquemas como 4-3-3, 4-4-2 y 4-2-3-1. Entre ellas, 4-2-3-1 destaca especialmente porque combina un rendimiento competitivo con una burbuja grande, es decir, con una muestra amplia de partidos, lo que hace más confiable la señal.</a:t>
+              <a:t>De este gráfico de líneas, podemos identificar cuatro etapas que definen la carrera de un futbolista profesional:</a:t>
             </a:r>
           </a:p>
           <a:p>
@@ -4284,7 +4304,37 @@
                 </a:solidFill>
                 <a:latin typeface="Aptos"/>
               </a:rPr>
-              <a:t>También aparecen algunas formaciones con buen desempeño, pero con menor respaldo de muestra, como 3-5-2 y otras variantes cercanas al bloque superior. Esto sugiere que pueden ser opciones interesantes, pero conviene ser más prudente al interpretarlas, ya que una menor frecuencia de uso hace más difícil separar un patrón estable de un resultado puntual.</a:t>
+              <a:t>- Fase de crecimiento: desde las edades más tempranas (16-18 años), la línea muestra una pendiente ascendente constante y pronunciada. Es en esta etapa donde los jugadores adquieren madurez táctica, experiencia y desarrollo físico.</a:t>
+            </a:r>
+            <a:br/>
+            <a:r>
+              <a:rPr sz="1800">
+                <a:solidFill>
+                  <a:srgbClr val="1F2937"/>
+                </a:solidFill>
+                <a:latin typeface="Aptos"/>
+              </a:rPr>
+              <a:t>- El "prime" o pico de rendimiento: la curva alcanza uno de sus puntos más altos y forma una "meseta" típica entre los 27 y los 31 años. Es en esta franja donde el jugador encuentra el balance perfecto: combina su máxima experiencia futbolística con un físico aún en óptimas condiciones.</a:t>
+            </a:r>
+            <a:br/>
+            <a:r>
+              <a:rPr sz="1800">
+                <a:solidFill>
+                  <a:srgbClr val="1F2937"/>
+                </a:solidFill>
+                <a:latin typeface="Aptos"/>
+              </a:rPr>
+              <a:t>- Fase de declive: a partir de los 32 años, la línea comienza un descenso evidente, reflejando la pérdida natural de capacidades físicas, como velocidad, explosividad o resistencia, que termina por afectar la valoración general.</a:t>
+            </a:r>
+            <a:br/>
+            <a:r>
+              <a:rPr sz="1800">
+                <a:solidFill>
+                  <a:srgbClr val="1F2937"/>
+                </a:solidFill>
+                <a:latin typeface="Aptos"/>
+              </a:rPr>
+              <a:t>- Outliers: El ascenso abrupto en jugadores de 35+ puede deberse a outliers. En este ambito hay que investigar más a fondo, pues puede ser que el promedio suba debido a que los jugadores más talentosos posponen su retiro, sesgando el resultado.</a:t>
             </a:r>
           </a:p>
           <a:p>
@@ -4300,7 +4350,7 @@
                 </a:solidFill>
                 <a:latin typeface="Aptos"/>
               </a:rPr>
-              <a:t>En el extremo opuesto, 5-3-2, 4-5-1 y 4-1-4-1 se ubican en la zona de peor balance, con menos puntos por partido y una diferencia de gol promedio más negativa. En conjunto, la gráfica sugiere que no basta con mirar qué formación se usa más: conviene priorizar esquemas que mantengan un equilibrio entre frecuencia y resultados, y en ese sentido 4-2-3-1 y 4-4-2 parecen alternativas más sólidas que otras formaciones menos consistentes.</a:t>
+              <a:t>Si el equipo busca éxito inmediato para competir por un campeonato, debe apostar por jugadores en su "prime" (27-30 años), sabiendo que su costo será el más elevado. En cambio, si la directiva busca construir un proyecto a mediano plazo y generar plusvalía, la inversión debe ir hacia la fase de crecimiento (20-23 años), adquiriendo talento cuyo rendimiento y valor de mercado estadísticamente irán al alza.</a:t>
             </a:r>
           </a:p>
         </p:txBody>
@@ -4339,8 +4389,8 @@
         </p:nvSpPr>
         <p:spPr>
           <a:xfrm>
-            <a:off x="640080" y="457200"/>
-            <a:ext cx="10058400" cy="457200"/>
+            <a:off x="822960" y="457200"/>
+            <a:ext cx="9601200" cy="914400"/>
           </a:xfrm>
           <a:prstGeom prst="rect">
             <a:avLst/>
@@ -4355,41 +4405,203 @@
           <a:p>
             <a:pPr algn="l"/>
             <a:r>
-              <a:rPr sz="2000" b="1">
+              <a:rPr sz="2600" b="1">
                 <a:solidFill>
                   <a:srgbClr val="1D4E89"/>
                 </a:solidFill>
                 <a:latin typeface="Aptos"/>
               </a:rPr>
-              <a:t>Analisis 01: ¿Qué atributos mirar en jugadores de campo?</a:t>
-            </a:r>
-          </a:p>
-        </p:txBody>
-      </p:sp>
-      <p:pic>
-        <p:nvPicPr>
-          <p:cNvPr id="3" name="Picture 2" descr="image.png"/>
-          <p:cNvPicPr>
-            <a:picLocks noChangeAspect="1"/>
-          </p:cNvPicPr>
+              <a:t>Entendiendo la base de datos.</a:t>
+            </a:r>
+          </a:p>
+        </p:txBody>
+      </p:sp>
+      <p:sp>
+        <p:nvSpPr>
+          <p:cNvPr id="3" name="TextBox 2"/>
+          <p:cNvSpPr txBox="1"/>
           <p:nvPr/>
-        </p:nvPicPr>
-        <p:blipFill>
-          <a:blip r:embed="rId2"/>
-          <a:stretch>
-            <a:fillRect/>
-          </a:stretch>
-        </p:blipFill>
-        <p:spPr>
-          <a:xfrm>
-            <a:off x="2651759" y="1188720"/>
-            <a:ext cx="6583680" cy="4937760"/>
+        </p:nvSpPr>
+        <p:spPr>
+          <a:xfrm>
+            <a:off x="822960" y="1005840"/>
+            <a:ext cx="9601200" cy="914400"/>
           </a:xfrm>
           <a:prstGeom prst="rect">
             <a:avLst/>
           </a:prstGeom>
-        </p:spPr>
-      </p:pic>
+          <a:noFill/>
+        </p:spPr>
+        <p:txBody>
+          <a:bodyPr wrap="square">
+            <a:spAutoFit/>
+          </a:bodyPr>
+          <a:lstStyle/>
+          <a:p>
+            <a:pPr algn="l"/>
+            <a:r>
+              <a:rPr sz="1800" b="0">
+                <a:solidFill>
+                  <a:srgbClr val="8D99AE"/>
+                </a:solidFill>
+                <a:latin typeface="Aptos"/>
+              </a:rPr>
+              <a:t>¿De dónde se obtuvo?, ¿Qué contiene?, ¿Cuáles son sus limitaciones?</a:t>
+            </a:r>
+          </a:p>
+        </p:txBody>
+      </p:sp>
+      <p:sp>
+        <p:nvSpPr>
+          <p:cNvPr id="4" name="TextBox 3"/>
+          <p:cNvSpPr txBox="1"/>
+          <p:nvPr/>
+        </p:nvSpPr>
+        <p:spPr>
+          <a:xfrm>
+            <a:off x="822960" y="1554480"/>
+            <a:ext cx="9601200" cy="3657600"/>
+          </a:xfrm>
+          <a:prstGeom prst="rect">
+            <a:avLst/>
+          </a:prstGeom>
+          <a:noFill/>
+        </p:spPr>
+        <p:txBody>
+          <a:bodyPr wrap="square">
+            <a:spAutoFit/>
+          </a:bodyPr>
+          <a:lstStyle/>
+          <a:p>
+            <a:pPr>
+              <a:spcAft>
+                <a:spcPts val="1000"/>
+              </a:spcAft>
+            </a:pPr>
+            <a:r>
+              <a:rPr sz="1800">
+                <a:solidFill>
+                  <a:srgbClr val="1F2937"/>
+                </a:solidFill>
+                <a:latin typeface="Aptos"/>
+              </a:rPr>
+              <a:t>La base de datos que utilizamos fue obtenida de Kaggle; su nombre, 'European Soccer Database'; el link del dataset es https://www.kaggle.com/datasets/hugomathien/soccer.</a:t>
+            </a:r>
+            <a:br/>
+            <a:r>
+              <a:rPr sz="1800">
+                <a:solidFill>
+                  <a:srgbClr val="1F2937"/>
+                </a:solidFill>
+                <a:latin typeface="Aptos"/>
+              </a:rPr>
+              <a:t>        </a:t>
+            </a:r>
+            <a:br/>
+            <a:r>
+              <a:rPr sz="1800">
+                <a:solidFill>
+                  <a:srgbClr val="1F2937"/>
+                </a:solidFill>
+                <a:latin typeface="Aptos"/>
+              </a:rPr>
+              <a:t>La base esta almacenada en un archivo .sqlite. Esta contiene información de partidos, jugadores, equipos y momios de partidos de equipos de primera división de ligas europeas. La información no es actual, esta data de registros del 2007 hasta registros del 2016.</a:t>
+            </a:r>
+          </a:p>
+          <a:p>
+            <a:pPr>
+              <a:spcAft>
+                <a:spcPts val="1000"/>
+              </a:spcAft>
+            </a:pPr>
+            <a:r>
+              <a:rPr sz="1800">
+                <a:solidFill>
+                  <a:srgbClr val="1F2937"/>
+                </a:solidFill>
+                <a:latin typeface="Aptos"/>
+              </a:rPr>
+              <a:t>La base de datos tiene en total las siguiente siete tablas:</a:t>
+            </a:r>
+          </a:p>
+          <a:p>
+            <a:pPr>
+              <a:spcAft>
+                <a:spcPts val="1000"/>
+              </a:spcAft>
+            </a:pPr>
+            <a:r>
+              <a:rPr sz="1800">
+                <a:solidFill>
+                  <a:srgbClr val="1F2937"/>
+                </a:solidFill>
+                <a:latin typeface="Aptos"/>
+              </a:rPr>
+              <a:t>- Player: Información básica de jugadores: nombre, fecha de nacimiento, altura, peso.</a:t>
+            </a:r>
+            <a:br/>
+            <a:r>
+              <a:rPr sz="1800">
+                <a:solidFill>
+                  <a:srgbClr val="1F2937"/>
+                </a:solidFill>
+                <a:latin typeface="Aptos"/>
+              </a:rPr>
+              <a:t>- Player_Attributes: Estadísticos de jugadores. Valores extraídos de los videojuegos de FIFA.</a:t>
+            </a:r>
+            <a:br/>
+            <a:r>
+              <a:rPr sz="1800">
+                <a:solidFill>
+                  <a:srgbClr val="1F2937"/>
+                </a:solidFill>
+                <a:latin typeface="Aptos"/>
+              </a:rPr>
+              <a:t>- Match: Registro de partidos. Informacion completa: fecha, equipos, visitante o casa, lineamiento, formacion, goles, eventos relevantes, momios, etc.</a:t>
+            </a:r>
+            <a:br/>
+            <a:r>
+              <a:rPr sz="1800">
+                <a:solidFill>
+                  <a:srgbClr val="1F2937"/>
+                </a:solidFill>
+                <a:latin typeface="Aptos"/>
+              </a:rPr>
+              <a:t>- League: Ids y nombres de ligas.</a:t>
+            </a:r>
+            <a:br/>
+            <a:r>
+              <a:rPr sz="1800">
+                <a:solidFill>
+                  <a:srgbClr val="1F2937"/>
+                </a:solidFill>
+                <a:latin typeface="Aptos"/>
+              </a:rPr>
+              <a:t>- Country: Ids y nombres de paises.</a:t>
+            </a:r>
+            <a:br/>
+            <a:r>
+              <a:rPr sz="1800">
+                <a:solidFill>
+                  <a:srgbClr val="1F2937"/>
+                </a:solidFill>
+                <a:latin typeface="Aptos"/>
+              </a:rPr>
+              <a:t>- Team: Ids y nombres de equipos.</a:t>
+            </a:r>
+            <a:br/>
+            <a:r>
+              <a:rPr sz="1800">
+                <a:solidFill>
+                  <a:srgbClr val="1F2937"/>
+                </a:solidFill>
+                <a:latin typeface="Aptos"/>
+              </a:rPr>
+              <a:t>- Team_Attributes: Estadísticos de equipos. Valores extraídos de los videojuegos de FIFA.</a:t>
+            </a:r>
+          </a:p>
+        </p:txBody>
+      </p:sp>
     </p:spTree>
   </p:cSld>
   <p:clrMapOvr>
@@ -4446,7 +4658,7 @@
                 </a:solidFill>
                 <a:latin typeface="Aptos"/>
               </a:rPr>
-              <a:t>Analisis 10: ¿Qué formaciones son más seguras o más riesgosas?</a:t>
+              <a:t>Analisis 09: ¿Qué formaciones equilibran uso y rendimiento?</a:t>
             </a:r>
           </a:p>
         </p:txBody>
@@ -4467,8 +4679,8 @@
         </p:blipFill>
         <p:spPr>
           <a:xfrm>
-            <a:off x="1711234" y="1188720"/>
-            <a:ext cx="8464731" cy="4937760"/>
+            <a:off x="2063931" y="1188720"/>
+            <a:ext cx="7759337" cy="4937760"/>
           </a:xfrm>
           <a:prstGeom prst="rect">
             <a:avLst/>
@@ -4531,7 +4743,7 @@
                 </a:solidFill>
                 <a:latin typeface="Aptos"/>
               </a:rPr>
-              <a:t>Lectura del análisis 10: ¿Qué formaciones son más seguras o más riesgosas?</a:t>
+              <a:t>Lectura del análisis 09: ¿Qué formaciones equilibran uso y rendimiento?</a:t>
             </a:r>
           </a:p>
         </p:txBody>
@@ -4570,7 +4782,7 @@
                 </a:solidFill>
                 <a:latin typeface="Aptos"/>
               </a:rPr>
-              <a:t>Desde una perspectiva táctica, el gráfico sugiere que las formaciones pueden clasificarse según su perfil de riesgo: esquemas agresivos para contextos donde ganar es prioritario, y esquemas más sólidos para torneos largos o partidos donde minimizar derrotas es más importante. Tanto para entrenadores como analistas, esto permite evaluar formaciones no solo por porcentaje de victorias, sino por la distribución completa de resultados. Así, una formación con menos derrotas y más empates puede ser más valiosa en ciertos contextos competitivos que otra con más victorias, pero también con mayor inestabilidad en sus resultados.</a:t>
+              <a:t>¿Qué problema se aborda en este análisis?</a:t>
             </a:r>
           </a:p>
           <a:p>
@@ -4586,7 +4798,71 @@
                 </a:solidFill>
                 <a:latin typeface="Aptos"/>
               </a:rPr>
-              <a:t>Este análisis es una interpretación más “superficial” ya que la cantidad de formaciones analizadas no se toma en cuenta. Esto sesga los resultados y hace que algunas formaciones (como la 3-2-3-2) parezcan aparentemente más efectivas, pero esto se debe a que su muestra es más reducida. A diferencia de la diapositiva anterior donde se consideran muestras más amplias y con mejor representación, por lo que sus conclusiones pueden ser más definitivas y tener un mejor enfoque de comparación.</a:t>
+              <a:t>Evaluar la relación entre el rendimiento, la frecuencia de uso y la proporción/tasa de partidos en casa de las 10 formaciones más utilizadas.</a:t>
+            </a:r>
+          </a:p>
+          <a:p>
+            <a:pPr>
+              <a:spcAft>
+                <a:spcPts val="1000"/>
+              </a:spcAft>
+            </a:pPr>
+            <a:r>
+              <a:rPr sz="1800">
+                <a:solidFill>
+                  <a:srgbClr val="1F2937"/>
+                </a:solidFill>
+                <a:latin typeface="Aptos"/>
+              </a:rPr>
+              <a:t>Los insights:</a:t>
+            </a:r>
+          </a:p>
+          <a:p>
+            <a:pPr>
+              <a:spcAft>
+                <a:spcPts val="1000"/>
+              </a:spcAft>
+            </a:pPr>
+            <a:r>
+              <a:rPr sz="1800">
+                <a:solidFill>
+                  <a:srgbClr val="1F2937"/>
+                </a:solidFill>
+                <a:latin typeface="Aptos"/>
+              </a:rPr>
+              <a:t>Las formaciones más usadas en general tienden a, en general, traer mejores resultados para el equipo que las utilice, y no parece haber un impacto relevante en si la formación fue utilizada por un equipo local o visitante. De la gráfica obtenemos que las formaciones 4-3-3, 4-3-1-2, 4-4-2 y 4-1-2-1-2 son las más sólidas, pues son las únicas con una diferencia de gol promedio positiva. De estas la formación 4-4-2 y la formación 4-3-3 son las que tienen una señal mas significativa, pues de su tamaño de burbuja inferimos que la muestra es más grande, y por tanto, describe mejor el promedio real de la población.</a:t>
+            </a:r>
+          </a:p>
+          <a:p>
+            <a:pPr>
+              <a:spcAft>
+                <a:spcPts val="1000"/>
+              </a:spcAft>
+            </a:pPr>
+            <a:r>
+              <a:rPr sz="1800">
+                <a:solidFill>
+                  <a:srgbClr val="1F2937"/>
+                </a:solidFill>
+                <a:latin typeface="Aptos"/>
+              </a:rPr>
+              <a:t>Insights ejecutables:</a:t>
+            </a:r>
+          </a:p>
+          <a:p>
+            <a:pPr>
+              <a:spcAft>
+                <a:spcPts val="1000"/>
+              </a:spcAft>
+            </a:pPr>
+            <a:r>
+              <a:rPr sz="1800">
+                <a:solidFill>
+                  <a:srgbClr val="1F2937"/>
+                </a:solidFill>
+                <a:latin typeface="Aptos"/>
+              </a:rPr>
+              <a:t>En base a los resultados observados, podemos recomendar al equipo técnico que considere optar por las formaciones antes mencionadas; y podríamos recomendar precaución con aquellas con una muestra de menor tamaño (4-1-2-1-2 y 4-3-1-2). Además, este análisis nos ayudara a comprender el siguiente análisis y plantear insights más robustos.</a:t>
             </a:r>
           </a:p>
         </p:txBody>
@@ -4625,6 +4901,207 @@
         </p:nvSpPr>
         <p:spPr>
           <a:xfrm>
+            <a:off x="640080" y="457200"/>
+            <a:ext cx="10058400" cy="457200"/>
+          </a:xfrm>
+          <a:prstGeom prst="rect">
+            <a:avLst/>
+          </a:prstGeom>
+          <a:noFill/>
+        </p:spPr>
+        <p:txBody>
+          <a:bodyPr wrap="square">
+            <a:spAutoFit/>
+          </a:bodyPr>
+          <a:lstStyle/>
+          <a:p>
+            <a:pPr algn="l"/>
+            <a:r>
+              <a:rPr sz="2000" b="1">
+                <a:solidFill>
+                  <a:srgbClr val="1D4E89"/>
+                </a:solidFill>
+                <a:latin typeface="Aptos"/>
+              </a:rPr>
+              <a:t>Analisis 10: ¿Qué formaciones son más seguras o más riesgosas?</a:t>
+            </a:r>
+          </a:p>
+        </p:txBody>
+      </p:sp>
+      <p:pic>
+        <p:nvPicPr>
+          <p:cNvPr id="3" name="Picture 2" descr="image.png"/>
+          <p:cNvPicPr>
+            <a:picLocks noChangeAspect="1"/>
+          </p:cNvPicPr>
+          <p:nvPr/>
+        </p:nvPicPr>
+        <p:blipFill>
+          <a:blip r:embed="rId2"/>
+          <a:stretch>
+            <a:fillRect/>
+          </a:stretch>
+        </p:blipFill>
+        <p:spPr>
+          <a:xfrm>
+            <a:off x="1711234" y="1188720"/>
+            <a:ext cx="8464731" cy="4937760"/>
+          </a:xfrm>
+          <a:prstGeom prst="rect">
+            <a:avLst/>
+          </a:prstGeom>
+        </p:spPr>
+      </p:pic>
+    </p:spTree>
+  </p:cSld>
+  <p:clrMapOvr>
+    <a:masterClrMapping/>
+  </p:clrMapOvr>
+</p:sld>
+</file>
+
+<file path=ppt/slides/slide23.xml><?xml version="1.0" encoding="utf-8"?>
+<p:sld xmlns:a="http://schemas.openxmlformats.org/drawingml/2006/main" xmlns:p="http://schemas.openxmlformats.org/presentationml/2006/main" xmlns:r="http://schemas.openxmlformats.org/officeDocument/2006/relationships">
+  <p:cSld>
+    <p:bg>
+      <p:bgPr>
+        <a:solidFill>
+          <a:srgbClr val="F7F7F2"/>
+        </a:solidFill>
+        <a:effectLst/>
+      </p:bgPr>
+    </p:bg>
+    <p:spTree>
+      <p:nvGrpSpPr>
+        <p:cNvPr id="1" name=""/>
+        <p:cNvGrpSpPr/>
+        <p:nvPr/>
+      </p:nvGrpSpPr>
+      <p:grpSpPr/>
+      <p:sp>
+        <p:nvSpPr>
+          <p:cNvPr id="2" name="TextBox 1"/>
+          <p:cNvSpPr txBox="1"/>
+          <p:nvPr/>
+        </p:nvSpPr>
+        <p:spPr>
+          <a:xfrm>
+            <a:off x="640080" y="457200"/>
+            <a:ext cx="10058400" cy="457200"/>
+          </a:xfrm>
+          <a:prstGeom prst="rect">
+            <a:avLst/>
+          </a:prstGeom>
+          <a:noFill/>
+        </p:spPr>
+        <p:txBody>
+          <a:bodyPr wrap="square">
+            <a:spAutoFit/>
+          </a:bodyPr>
+          <a:lstStyle/>
+          <a:p>
+            <a:pPr algn="l"/>
+            <a:r>
+              <a:rPr sz="2000" b="1">
+                <a:solidFill>
+                  <a:srgbClr val="2A9D8F"/>
+                </a:solidFill>
+                <a:latin typeface="Aptos"/>
+              </a:rPr>
+              <a:t>Lectura del análisis 10: ¿Qué formaciones son más seguras o más riesgosas?</a:t>
+            </a:r>
+          </a:p>
+        </p:txBody>
+      </p:sp>
+      <p:sp>
+        <p:nvSpPr>
+          <p:cNvPr id="3" name="TextBox 2"/>
+          <p:cNvSpPr txBox="1"/>
+          <p:nvPr/>
+        </p:nvSpPr>
+        <p:spPr>
+          <a:xfrm>
+            <a:off x="822960" y="1280160"/>
+            <a:ext cx="10241280" cy="5120640"/>
+          </a:xfrm>
+          <a:prstGeom prst="rect">
+            <a:avLst/>
+          </a:prstGeom>
+          <a:noFill/>
+        </p:spPr>
+        <p:txBody>
+          <a:bodyPr wrap="square">
+            <a:spAutoFit/>
+          </a:bodyPr>
+          <a:lstStyle/>
+          <a:p>
+            <a:pPr>
+              <a:spcAft>
+                <a:spcPts val="1000"/>
+              </a:spcAft>
+            </a:pPr>
+            <a:r>
+              <a:rPr sz="1800">
+                <a:solidFill>
+                  <a:srgbClr val="1F2937"/>
+                </a:solidFill>
+                <a:latin typeface="Aptos"/>
+              </a:rPr>
+              <a:t>Desde una perspectiva táctica, el gráfico sugiere que las formaciones pueden clasificarse según su perfil de riesgo: esquemas agresivos para contextos donde ganar es prioritario, y esquemas más sólidos para torneos largos o partidos donde minimizar derrotas es más importante. Tanto para entrenadores como analistas, esto permite evaluar formaciones no solo por porcentaje de victorias, sino por la distribución completa de resultados. Así, una formación con menos derrotas y más empates puede ser más valiosa en ciertos contextos competitivos que otra con más victorias, pero también con mayor inestabilidad en sus resultados.</a:t>
+            </a:r>
+          </a:p>
+          <a:p>
+            <a:pPr>
+              <a:spcAft>
+                <a:spcPts val="1000"/>
+              </a:spcAft>
+            </a:pPr>
+            <a:r>
+              <a:rPr sz="1800">
+                <a:solidFill>
+                  <a:srgbClr val="1F2937"/>
+                </a:solidFill>
+                <a:latin typeface="Aptos"/>
+              </a:rPr>
+              <a:t>Este análisis es una interpretación más “superficial” ya que la cantidad de formaciones analizadas no se toma en cuenta. Esto sesga los resultados y hace que algunas formaciones (como la 3-2-3-2) parezcan aparentemente más efectivas, pero esto se debe a que su muestra es más reducida. A diferencia de la diapositiva anterior donde se consideran muestras más amplias y con mejor representación, por lo que sus conclusiones pueden ser más definitivas y tener un mejor enfoque de comparación.</a:t>
+            </a:r>
+          </a:p>
+        </p:txBody>
+      </p:sp>
+    </p:spTree>
+  </p:cSld>
+  <p:clrMapOvr>
+    <a:masterClrMapping/>
+  </p:clrMapOvr>
+</p:sld>
+</file>
+
+<file path=ppt/slides/slide24.xml><?xml version="1.0" encoding="utf-8"?>
+<p:sld xmlns:a="http://schemas.openxmlformats.org/drawingml/2006/main" xmlns:p="http://schemas.openxmlformats.org/presentationml/2006/main" xmlns:r="http://schemas.openxmlformats.org/officeDocument/2006/relationships">
+  <p:cSld>
+    <p:bg>
+      <p:bgPr>
+        <a:solidFill>
+          <a:srgbClr val="F7F7F2"/>
+        </a:solidFill>
+        <a:effectLst/>
+      </p:bgPr>
+    </p:bg>
+    <p:spTree>
+      <p:nvGrpSpPr>
+        <p:cNvPr id="1" name=""/>
+        <p:cNvGrpSpPr/>
+        <p:nvPr/>
+      </p:nvGrpSpPr>
+      <p:grpSpPr/>
+      <p:sp>
+        <p:nvSpPr>
+          <p:cNvPr id="2" name="TextBox 1"/>
+          <p:cNvSpPr txBox="1"/>
+          <p:nvPr/>
+        </p:nvSpPr>
+        <p:spPr>
+          <a:xfrm>
             <a:off x="822960" y="1371600"/>
             <a:ext cx="4572000" cy="548640"/>
           </a:xfrm>
@@ -4773,8 +5250,8 @@
         </p:nvSpPr>
         <p:spPr>
           <a:xfrm>
-            <a:off x="640080" y="457200"/>
-            <a:ext cx="10058400" cy="457200"/>
+            <a:off x="822960" y="457200"/>
+            <a:ext cx="9601200" cy="914400"/>
           </a:xfrm>
           <a:prstGeom prst="rect">
             <a:avLst/>
@@ -4789,13 +5266,13 @@
           <a:p>
             <a:pPr algn="l"/>
             <a:r>
-              <a:rPr sz="2000" b="1">
-                <a:solidFill>
-                  <a:srgbClr val="2A9D8F"/>
-                </a:solidFill>
-                <a:latin typeface="Aptos"/>
-              </a:rPr>
-              <a:t>Lectura del análisis 01: ¿Qué atributos mirar en jugadores de campo?</a:t>
+              <a:rPr sz="2600" b="1">
+                <a:solidFill>
+                  <a:srgbClr val="1D4E89"/>
+                </a:solidFill>
+                <a:latin typeface="Aptos"/>
+              </a:rPr>
+              <a:t>Dirección del análisis.</a:t>
             </a:r>
           </a:p>
         </p:txBody>
@@ -4808,8 +5285,43 @@
         </p:nvSpPr>
         <p:spPr>
           <a:xfrm>
-            <a:off x="822960" y="1280160"/>
-            <a:ext cx="10241280" cy="5120640"/>
+            <a:off x="822960" y="1005840"/>
+            <a:ext cx="9601200" cy="914400"/>
+          </a:xfrm>
+          <a:prstGeom prst="rect">
+            <a:avLst/>
+          </a:prstGeom>
+          <a:noFill/>
+        </p:spPr>
+        <p:txBody>
+          <a:bodyPr wrap="square">
+            <a:spAutoFit/>
+          </a:bodyPr>
+          <a:lstStyle/>
+          <a:p>
+            <a:pPr algn="l"/>
+            <a:r>
+              <a:rPr sz="1800" b="0">
+                <a:solidFill>
+                  <a:srgbClr val="8D99AE"/>
+                </a:solidFill>
+                <a:latin typeface="Aptos"/>
+              </a:rPr>
+              <a:t>¿Para quién esta dirigido este análisis?, ¿Qué tipo de insights planteamos obtener?</a:t>
+            </a:r>
+          </a:p>
+        </p:txBody>
+      </p:sp>
+      <p:sp>
+        <p:nvSpPr>
+          <p:cNvPr id="4" name="TextBox 3"/>
+          <p:cNvSpPr txBox="1"/>
+          <p:nvPr/>
+        </p:nvSpPr>
+        <p:spPr>
+          <a:xfrm>
+            <a:off x="822960" y="1554480"/>
+            <a:ext cx="9601200" cy="3657600"/>
           </a:xfrm>
           <a:prstGeom prst="rect">
             <a:avLst/>
@@ -4834,7 +5346,7 @@
                 </a:solidFill>
                 <a:latin typeface="Aptos"/>
               </a:rPr>
-              <a:t>¿Qué problema intentamos resolver con nuestro análisis?</a:t>
+              <a:t>Como dirección del análisis escogimos el ayudar a directores técnicos y personal encargado de scouter jugadores de equipos de ligas europeas de primera división. El objetivo es obtener insights relevantes que puedan ayudar a una de tres cosas:</a:t>
             </a:r>
           </a:p>
           <a:p>
@@ -4850,7 +5362,27 @@
                 </a:solidFill>
                 <a:latin typeface="Aptos"/>
               </a:rPr>
-              <a:t>El scouting tradicional pierde tiempo evaluando decenas de atributos por jugador. Esto genera exceso de información y retrasa la toma de decisiones durante las ventanas de fichajes.</a:t>
+              <a:t>- Mejorar toma de decisiones tácticas.</a:t>
+            </a:r>
+            <a:br/>
+            <a:r>
+              <a:rPr sz="1800">
+                <a:solidFill>
+                  <a:srgbClr val="1F2937"/>
+                </a:solidFill>
+                <a:latin typeface="Aptos"/>
+              </a:rPr>
+              <a:t>- Ayudar a facilitar el proceso de scouting de nuevos jugadores.</a:t>
+            </a:r>
+            <a:br/>
+            <a:r>
+              <a:rPr sz="1800">
+                <a:solidFill>
+                  <a:srgbClr val="1F2937"/>
+                </a:solidFill>
+                <a:latin typeface="Aptos"/>
+              </a:rPr>
+              <a:t>- Ayudar a mejorar el proceso de valuación de jugadores.</a:t>
             </a:r>
           </a:p>
           <a:p>
@@ -4866,7 +5398,7 @@
                 </a:solidFill>
                 <a:latin typeface="Aptos"/>
               </a:rPr>
-              <a:t>Solución propuesta:</a:t>
+              <a:t>Para esto, asumimos que la información de los atributos de jugadores es real y precisa. En realidad esto no es así, pues estos datos se obtienen de los videojuegos de FIFA, los cuales si bien sí se basan en análisis reales, terminan siendo modificados para balancer el videojuego.</a:t>
             </a:r>
           </a:p>
           <a:p>
@@ -4882,39 +5414,7 @@
                 </a:solidFill>
                 <a:latin typeface="Aptos"/>
               </a:rPr>
-              <a:t>La matriz de correlación demuestra matemáticamente que los atributos se agrupan en "bloques". Por ejemplo, Velocidad y Aceleración son prácticamente el mismo dato (0.89 de similitud), al igual que Regate y Control de Balón (0.85). No necesitamos analizar 20 variables independientes.</a:t>
-            </a:r>
-          </a:p>
-          <a:p>
-            <a:pPr>
-              <a:spcAft>
-                <a:spcPts val="1000"/>
-              </a:spcAft>
-            </a:pPr>
-            <a:r>
-              <a:rPr sz="1800">
-                <a:solidFill>
-                  <a:srgbClr val="1F2937"/>
-                </a:solidFill>
-                <a:latin typeface="Aptos"/>
-              </a:rPr>
-              <a:t>Implicación del negocio:</a:t>
-            </a:r>
-          </a:p>
-          <a:p>
-            <a:pPr>
-              <a:spcAft>
-                <a:spcPts val="1000"/>
-              </a:spcAft>
-            </a:pPr>
-            <a:r>
-              <a:rPr sz="1800">
-                <a:solidFill>
-                  <a:srgbClr val="1F2937"/>
-                </a:solidFill>
-                <a:latin typeface="Aptos"/>
-              </a:rPr>
-              <a:t>Esto nos permite reducir a la mitad los indicadores clave de rendimiento (KPIs) Podemos crear un filtro automatizado mucho más ágil. En lugar de buscar "el jugador perfecto en 20 atributos", el equipo de scouting puede enfocarse en evaluar 4 o 5 "bloques o perfiles" fundamentales. Esto acelera el descarte de jugadores que no encajan en el club, optimiza las horas de trabajo de los visores y reduce el riesgo económico en los fichajes.</a:t>
+              <a:t>Dado el enfoque del análisis, no hicimos uso de la informacion de estadísticos por equipo ni de las estadisticas de los momios de los partidos. Esta información puede ser útil, pero no para ninguno de los tres objetivos principales planteados para este análisis.</a:t>
             </a:r>
           </a:p>
         </p:txBody>
@@ -4975,7 +5475,7 @@
                 </a:solidFill>
                 <a:latin typeface="Aptos"/>
               </a:rPr>
-              <a:t>Analisis 02: ¿Qué atributos mirar en porteros?</a:t>
+              <a:t>Analisis 01: ¿Qué atributos mirar en jugadores de campo?</a:t>
             </a:r>
           </a:p>
         </p:txBody>
@@ -5060,7 +5560,7 @@
                 </a:solidFill>
                 <a:latin typeface="Aptos"/>
               </a:rPr>
-              <a:t>Lectura del análisis 02: ¿Qué atributos mirar en porteros?</a:t>
+              <a:t>Lectura del análisis 01: ¿Qué atributos mirar en jugadores de campo?</a:t>
             </a:r>
           </a:p>
         </p:txBody>
@@ -5099,7 +5599,7 @@
                 </a:solidFill>
                 <a:latin typeface="Aptos"/>
               </a:rPr>
-              <a:t>¿Qué problema intentamos solucionar con nuestro análisis?</a:t>
+              <a:t>¿Qué problema intentamos resolver con nuestro análisis?</a:t>
             </a:r>
           </a:p>
           <a:p>
@@ -5115,7 +5615,7 @@
                 </a:solidFill>
                 <a:latin typeface="Aptos"/>
               </a:rPr>
-              <a:t>La evaluación de porteros suele basarse en una sobrecarga de métricas redundantes, lo que ralentiza la identificación de talento y encarece la adquisición de datos y herramientas de scouting.</a:t>
+              <a:t>El scouting tradicional pierde tiempo evaluando decenas de atributos por jugador. Esto genera exceso de información y retrasa la toma de decisiones durante las ventanas de fichajes.</a:t>
             </a:r>
           </a:p>
           <a:p>
@@ -5131,7 +5631,7 @@
                 </a:solidFill>
                 <a:latin typeface="Aptos"/>
               </a:rPr>
-              <a:t>¿Qué solución se propone?</a:t>
+              <a:t>Solución propuesta:</a:t>
             </a:r>
           </a:p>
           <a:p>
@@ -5147,7 +5647,7 @@
                 </a:solidFill>
                 <a:latin typeface="Aptos"/>
               </a:rPr>
-              <a:t>Habilidades como Estirada (Diving) y Reflejos (0.89), o Colocación (Positioning) y Manejo (Handling) (0.83), son indivisibles. En la práctica, un portero que sabe ubicarse raramente da rebotes peligrosos. El entrenamiento y el scouting deben evaluar estos pares de forma conjunta, no aislada. Se detecta una variable aislada, el salto (Jumping) nos indica que la calidad de un portero se centra más en técnica y ubicación, no en atletismo puro.</a:t>
+              <a:t>La matriz de correlación demuestra matemáticamente que los atributos se agrupan en "bloques". Por ejemplo, Velocidad y Aceleración son prácticamente el mismo dato (0.89 de similitud), al igual que Regate y Control de Balón (0.85). No necesitamos analizar 20 variables independientes.</a:t>
             </a:r>
           </a:p>
           <a:p>
@@ -5163,7 +5663,7 @@
                 </a:solidFill>
                 <a:latin typeface="Aptos"/>
               </a:rPr>
-              <a:t>¿Qué utilidad trae al negocio el análisis?</a:t>
+              <a:t>Implicación del negocio:</a:t>
             </a:r>
           </a:p>
           <a:p>
@@ -5179,7 +5679,7 @@
                 </a:solidFill>
                 <a:latin typeface="Aptos"/>
               </a:rPr>
-              <a:t>Hacer que auditar 15 atributos distintos por portero no sea necesario da un incremento significativo en el ahorro de tiempo y dinero. El sistema de scouting se puede automatizar con solo 2 o 3 métricas clave, ahorrando cientos de horas de análisis de video y datos, asimismo ayuda a identificar “gangas” en el mercado. Al saber que el rendimiento general el predecible se pueden filtrar bases de datos en segundos para encontrar porteros de ligas menores con el mismo perfil estadístico que opciones mucho más caras.</a:t>
+              <a:t>Esto nos permite reducir a la mitad los indicadores clave de rendimiento (KPIs) Podemos crear un filtro automatizado mucho más ágil. En lugar de buscar "el jugador perfecto en 20 atributos", el equipo de scouting puede enfocarse en evaluar 4 o 5 "bloques o perfiles" fundamentales. Esto acelera el descarte de jugadores que no encajan en el club, optimiza las horas de trabajo de los visores y reduce el riesgo económico en los fichajes.</a:t>
             </a:r>
           </a:p>
         </p:txBody>
@@ -5240,7 +5740,7 @@
                 </a:solidFill>
                 <a:latin typeface="Aptos"/>
               </a:rPr>
-              <a:t>Analisis 03: ¿Cuánto margen tienen los campistas jovenes?</a:t>
+              <a:t>Analisis 02: ¿Qué atributos mirar en porteros?</a:t>
             </a:r>
           </a:p>
         </p:txBody>
@@ -5261,8 +5761,8 @@
         </p:blipFill>
         <p:spPr>
           <a:xfrm>
-            <a:off x="1005839" y="1188720"/>
-            <a:ext cx="9875520" cy="4937760"/>
+            <a:off x="2651759" y="1188720"/>
+            <a:ext cx="6583680" cy="4937760"/>
           </a:xfrm>
           <a:prstGeom prst="rect">
             <a:avLst/>
@@ -5325,7 +5825,7 @@
                 </a:solidFill>
                 <a:latin typeface="Aptos"/>
               </a:rPr>
-              <a:t>Lectura del análisis 03: ¿Cuánto margen tienen los campistas jovenes?</a:t>
+              <a:t>Lectura del análisis 02: ¿Qué atributos mirar en porteros?</a:t>
             </a:r>
           </a:p>
         </p:txBody>
@@ -5364,7 +5864,7 @@
                 </a:solidFill>
                 <a:latin typeface="Aptos"/>
               </a:rPr>
-              <a:t>¿Qué problema se trata en este análisis?</a:t>
+              <a:t>¿Qué problema intentamos solucionar con nuestro análisis?</a:t>
             </a:r>
           </a:p>
           <a:p>
@@ -5380,7 +5880,7 @@
                 </a:solidFill>
                 <a:latin typeface="Aptos"/>
               </a:rPr>
-              <a:t>Al fichar talento joven (18 – 23 años), los clubes suelen guiarse por la intuición sobre "cuánto puede mejorar" un jugador, asumiendo riesgos financieros altos sin un parámetro de lo que es un crecimiento normal frente a uno excepcional.</a:t>
+              <a:t>La evaluación de porteros suele basarse en una sobrecarga de métricas redundantes, lo que ralentiza la identificación de talento y encarece la adquisición de datos y herramientas de scouting.</a:t>
             </a:r>
           </a:p>
           <a:p>
@@ -5412,7 +5912,7 @@
                 </a:solidFill>
                 <a:latin typeface="Aptos"/>
               </a:rPr>
-              <a:t>Este análisis se basa exclusivamente en un conjunto de datos de ligas de primera división europea. En base al histograma, podemos observar que el margen de crecimiento (gap) de un prospecto joven incluido en este dataset tiende a concentrarse entre los 7 y 10 puntos. Este comportamiento de la muestra define nuestro estándar de mercado.</a:t>
+              <a:t>Habilidades como Estirada (Diving) y Reflejos (0.89), o Colocación (Positioning) y Manejo (Handling) (0.83), son indivisibles. En la práctica, un portero que sabe ubicarse raramente da rebotes peligrosos. El entrenamiento y el scouting deben evaluar estos pares de forma conjunta, no aislada. Se detecta una variable aislada, el salto (Jumping) no parece impactar mucho el overall rating de un portero, por lo cual la identificamos como un atriibuto secundario.</a:t>
             </a:r>
           </a:p>
           <a:p>
@@ -5428,7 +5928,7 @@
                 </a:solidFill>
                 <a:latin typeface="Aptos"/>
               </a:rPr>
-              <a:t>¿Qué implicaciones hay para el negocio?</a:t>
+              <a:t>¿Qué utilidad trae al negocio el análisis?</a:t>
             </a:r>
           </a:p>
           <a:p>
@@ -5444,7 +5944,7 @@
                 </a:solidFill>
                 <a:latin typeface="Aptos"/>
               </a:rPr>
-              <a:t>El departamento de scouting debe prestar menos atención al centro de la gráfica y enfocarse exclusivamente en la "cola derecha" (prospectos con un gap mayor a 12-14 puntos). Estos son los "activos infravalorados": jugadores cuyo costo de transferencia actual es bajo porque su rendimiento inmediato no refleja su techo real. Aquí es donde el club puede comprar barato y vender caro.</a:t>
+              <a:t>Hacer que auditar 7 atributos distintos por portero no sea necesario da un incremento significativo en el ahorro de tiempo y dinero. El sistema de scouting se puede automatizar con solo 2 o 3 métricas clave, ahorrando cientos de horas de análisis de video y datos, asimismo ayuda a identificar “gangas” en el mercado. Al saber que el rendimiento general el predecible se pueden filtrar bases de datos en segundos para encontrar porteros de ligas menores con el mismo perfil estadístico que opciones mucho más caras.</a:t>
             </a:r>
           </a:p>
         </p:txBody>
@@ -5505,7 +6005,7 @@
                 </a:solidFill>
                 <a:latin typeface="Aptos"/>
               </a:rPr>
-              <a:t>Analisis 04: ¿Cuánto margen tienen los porteros jovenes?</a:t>
+              <a:t>Analisis 03: ¿Cuánto margen tienen los campistas jovenes?</a:t>
             </a:r>
           </a:p>
         </p:txBody>
@@ -5590,7 +6090,7 @@
                 </a:solidFill>
                 <a:latin typeface="Aptos"/>
               </a:rPr>
-              <a:t>Lectura del análisis 04: ¿Cuánto margen tienen los porteros jovenes?</a:t>
+              <a:t>Lectura del análisis 03: ¿Cuánto margen tienen los campistas jovenes?</a:t>
             </a:r>
           </a:p>
         </p:txBody>
@@ -5629,7 +6129,7 @@
                 </a:solidFill>
                 <a:latin typeface="Aptos"/>
               </a:rPr>
-              <a:t>¿Qué problema se aborda en este análisis?</a:t>
+              <a:t>¿Qué problema se trata en este análisis?</a:t>
             </a:r>
           </a:p>
           <a:p>
@@ -5645,7 +6145,7 @@
                 </a:solidFill>
                 <a:latin typeface="Aptos"/>
               </a:rPr>
-              <a:t>Evaluar el talento y el techo de los porteros jóvenes (18-23 años) es uno de los mayores retos en el mercado, ya que su curva de maduración suele diferir de la del resto del equipo. Asumir riesgos financieros basándose solo en la intuición puede resultar en inversiones estancadas.</a:t>
+              <a:t>Al fichar talento joven (18 – 23 años), los clubes suelen guiarse por la intuición sobre "cuánto puede mejorar" un jugador, asumiendo riesgos financieros altos sin un parámetro de lo que es un crecimiento normal frente a uno excepcional.</a:t>
             </a:r>
           </a:p>
           <a:p>
@@ -5661,7 +6161,7 @@
                 </a:solidFill>
                 <a:latin typeface="Aptos"/>
               </a:rPr>
-              <a:t>¿Qué solución se presenta?</a:t>
+              <a:t>¿Qué solución se propone?</a:t>
             </a:r>
           </a:p>
           <a:p>
@@ -5677,7 +6177,7 @@
                 </a:solidFill>
                 <a:latin typeface="Aptos"/>
               </a:rPr>
-              <a:t>Este análisis se basa exclusivamente en un conjunto de datos de ligas de primera división europea. En base al histograma, podemos observar que el margen de crecimiento (gap) de los arqueros jóvenes incluidos en este dataset tiende a concentrarse principalmente entre los 7 y 12 puntos, con una mediana cercana a 9. Este comportamiento observado en la muestra define nuestro estándar de mercado para la posición.</a:t>
+              <a:t>Este análisis se basa exclusivamente en un conjunto de datos de ligas de primera división europea. En base al histograma, podemos observar que el margen de crecimiento (gap) de un prospecto joven incluido en este dataset tiende a concentrarse entre los 7 y 10 puntos. Este comportamiento de la muestra define nuestro estándar de mercado.</a:t>
             </a:r>
           </a:p>
           <a:p>
@@ -5693,7 +6193,7 @@
                 </a:solidFill>
                 <a:latin typeface="Aptos"/>
               </a:rPr>
-              <a:t>¿Qué implicaciones tiene para el negocio?</a:t>
+              <a:t>¿Qué implicaciones hay para el negocio?</a:t>
             </a:r>
           </a:p>
           <a:p>
@@ -5709,7 +6209,7 @@
                 </a:solidFill>
                 <a:latin typeface="Aptos"/>
               </a:rPr>
-              <a:t>El departamento de scouting debe enfocar sus recursos en la "cola derecha" de la distribución. Estos casos atípicos representan arqueros que combinan un nivel actual todavía contenido con un techo estimado mucho más alto. Identificarlos permite adquirir prospectos prometedores a un costo de transferencia inicial bajo, maximizando la plusvalía a largo plazo.</a:t>
+              <a:t>El departamento de scouting debe prestar menos atención al centro de la gráfica y enfocarse exclusivamente en la "cola derecha" (prospectos con un gap mayor a 12-14 puntos). Estos son los "activos infravalorados": jugadores cuyo costo de transferencia actual es bajo porque su rendimiento inmediato no refleja su techo real. Aquí es donde el club puede comprar barato y vender caro.</a:t>
             </a:r>
           </a:p>
         </p:txBody>

</xml_diff>